<commit_message>
replaced hit-by-bus title with lottery winner and added photo of Weirs
</commit_message>
<xml_diff>
--- a/instructors/01-Why_are_we_here.pptx
+++ b/instructors/01-Why_are_we_here.pptx
@@ -220,7 +220,7 @@
           <a:p>
             <a:fld id="{B1D4AFAA-5545-4348-866E-082827204B28}" type="datetimeFigureOut">
               <a:rPr lang="en-GB" smtClean="0"/>
-              <a:t>21/07/2022</a:t>
+              <a:t>08/08/2022</a:t>
             </a:fld>
             <a:endParaRPr lang="en-GB"/>
           </a:p>
@@ -569,6 +569,98 @@
 </p:notes>
 </file>
 
+<file path=ppt/notesSlides/notesSlide2.xml><?xml version="1.0" encoding="utf-8"?>
+<p:notes xmlns:a="http://schemas.openxmlformats.org/drawingml/2006/main" xmlns:r="http://schemas.openxmlformats.org/officeDocument/2006/relationships" xmlns:p="http://schemas.openxmlformats.org/presentationml/2006/main">
+  <p:cSld>
+    <p:spTree>
+      <p:nvGrpSpPr>
+        <p:cNvPr id="1" name=""/>
+        <p:cNvGrpSpPr/>
+        <p:nvPr/>
+      </p:nvGrpSpPr>
+      <p:grpSpPr>
+        <a:xfrm>
+          <a:off x="0" y="0"/>
+          <a:ext cx="0" cy="0"/>
+          <a:chOff x="0" y="0"/>
+          <a:chExt cx="0" cy="0"/>
+        </a:xfrm>
+      </p:grpSpPr>
+      <p:sp>
+        <p:nvSpPr>
+          <p:cNvPr id="2" name="Slide Image Placeholder 1"/>
+          <p:cNvSpPr>
+            <a:spLocks noGrp="1" noRot="1" noChangeAspect="1"/>
+          </p:cNvSpPr>
+          <p:nvPr>
+            <p:ph type="sldImg"/>
+          </p:nvPr>
+        </p:nvSpPr>
+        <p:spPr/>
+      </p:sp>
+      <p:sp>
+        <p:nvSpPr>
+          <p:cNvPr id="3" name="Notes Placeholder 2"/>
+          <p:cNvSpPr>
+            <a:spLocks noGrp="1"/>
+          </p:cNvSpPr>
+          <p:nvPr>
+            <p:ph type="body" idx="1"/>
+          </p:nvPr>
+        </p:nvSpPr>
+        <p:spPr/>
+        <p:txBody>
+          <a:bodyPr/>
+          <a:lstStyle/>
+          <a:p>
+            <a:r>
+              <a:rPr lang="en-GB" smtClean="0"/>
+              <a:t>Colin and Chris Weir are a Scottish couple who won</a:t>
+            </a:r>
+            <a:r>
+              <a:rPr lang="en-GB" baseline="0" smtClean="0"/>
+              <a:t> a life-changing sum of money in the national lottery. Would your postdoc come back into work if they hit the jackpot? </a:t>
+            </a:r>
+            <a:endParaRPr lang="en-GB"/>
+          </a:p>
+        </p:txBody>
+      </p:sp>
+      <p:sp>
+        <p:nvSpPr>
+          <p:cNvPr id="4" name="Slide Number Placeholder 3"/>
+          <p:cNvSpPr>
+            <a:spLocks noGrp="1"/>
+          </p:cNvSpPr>
+          <p:nvPr>
+            <p:ph type="sldNum" sz="quarter" idx="10"/>
+          </p:nvPr>
+        </p:nvSpPr>
+        <p:spPr/>
+        <p:txBody>
+          <a:bodyPr/>
+          <a:lstStyle/>
+          <a:p>
+            <a:fld id="{ECFFB44E-D000-426C-9F9B-769AE7CC186C}" type="slidenum">
+              <a:rPr lang="en-GB" smtClean="0"/>
+              <a:t>21</a:t>
+            </a:fld>
+            <a:endParaRPr lang="en-GB"/>
+          </a:p>
+        </p:txBody>
+      </p:sp>
+    </p:spTree>
+    <p:extLst>
+      <p:ext uri="{BB962C8B-B14F-4D97-AF65-F5344CB8AC3E}">
+        <p14:creationId xmlns:p14="http://schemas.microsoft.com/office/powerpoint/2010/main" val="3909621395"/>
+      </p:ext>
+    </p:extLst>
+  </p:cSld>
+  <p:clrMapOvr>
+    <a:masterClrMapping/>
+  </p:clrMapOvr>
+</p:notes>
+</file>
+
 <file path=ppt/slideLayouts/slideLayout1.xml><?xml version="1.0" encoding="utf-8"?>
 <p:sldLayout xmlns:a="http://schemas.openxmlformats.org/drawingml/2006/main" xmlns:r="http://schemas.openxmlformats.org/officeDocument/2006/relationships" xmlns:p="http://schemas.openxmlformats.org/presentationml/2006/main" type="title" preserve="1">
   <p:cSld name="Title Slide">
@@ -700,7 +792,7 @@
           <a:p>
             <a:fld id="{CC29EC85-173F-467E-B364-65AD14726A23}" type="datetimeFigureOut">
               <a:rPr lang="en-GB" smtClean="0"/>
-              <a:t>21/07/2022</a:t>
+              <a:t>08/08/2022</a:t>
             </a:fld>
             <a:endParaRPr lang="en-GB"/>
           </a:p>
@@ -917,7 +1009,7 @@
           <a:p>
             <a:fld id="{CC29EC85-173F-467E-B364-65AD14726A23}" type="datetimeFigureOut">
               <a:rPr lang="en-GB" smtClean="0"/>
-              <a:t>21/07/2022</a:t>
+              <a:t>08/08/2022</a:t>
             </a:fld>
             <a:endParaRPr lang="en-GB"/>
           </a:p>
@@ -1097,7 +1189,7 @@
           <a:p>
             <a:fld id="{CC29EC85-173F-467E-B364-65AD14726A23}" type="datetimeFigureOut">
               <a:rPr lang="en-GB" smtClean="0"/>
-              <a:t>21/07/2022</a:t>
+              <a:t>08/08/2022</a:t>
             </a:fld>
             <a:endParaRPr lang="en-GB"/>
           </a:p>
@@ -1460,7 +1552,7 @@
           <a:p>
             <a:fld id="{CC29EC85-173F-467E-B364-65AD14726A23}" type="datetimeFigureOut">
               <a:rPr lang="en-GB" smtClean="0"/>
-              <a:t>21/07/2022</a:t>
+              <a:t>08/08/2022</a:t>
             </a:fld>
             <a:endParaRPr lang="en-GB"/>
           </a:p>
@@ -1706,7 +1798,7 @@
           <a:p>
             <a:fld id="{CC29EC85-173F-467E-B364-65AD14726A23}" type="datetimeFigureOut">
               <a:rPr lang="en-GB" smtClean="0"/>
-              <a:t>21/07/2022</a:t>
+              <a:t>08/08/2022</a:t>
             </a:fld>
             <a:endParaRPr lang="en-GB"/>
           </a:p>
@@ -1938,7 +2030,7 @@
           <a:p>
             <a:fld id="{CC29EC85-173F-467E-B364-65AD14726A23}" type="datetimeFigureOut">
               <a:rPr lang="en-GB" smtClean="0"/>
-              <a:t>21/07/2022</a:t>
+              <a:t>08/08/2022</a:t>
             </a:fld>
             <a:endParaRPr lang="en-GB"/>
           </a:p>
@@ -2305,7 +2397,7 @@
           <a:p>
             <a:fld id="{CC29EC85-173F-467E-B364-65AD14726A23}" type="datetimeFigureOut">
               <a:rPr lang="en-GB" smtClean="0"/>
-              <a:t>21/07/2022</a:t>
+              <a:t>08/08/2022</a:t>
             </a:fld>
             <a:endParaRPr lang="en-GB"/>
           </a:p>
@@ -2423,7 +2515,7 @@
           <a:p>
             <a:fld id="{CC29EC85-173F-467E-B364-65AD14726A23}" type="datetimeFigureOut">
               <a:rPr lang="en-GB" smtClean="0"/>
-              <a:t>21/07/2022</a:t>
+              <a:t>08/08/2022</a:t>
             </a:fld>
             <a:endParaRPr lang="en-GB"/>
           </a:p>
@@ -2518,7 +2610,7 @@
           <a:p>
             <a:fld id="{CC29EC85-173F-467E-B364-65AD14726A23}" type="datetimeFigureOut">
               <a:rPr lang="en-GB" smtClean="0"/>
-              <a:t>21/07/2022</a:t>
+              <a:t>08/08/2022</a:t>
             </a:fld>
             <a:endParaRPr lang="en-GB"/>
           </a:p>
@@ -2795,7 +2887,7 @@
           <a:p>
             <a:fld id="{CC29EC85-173F-467E-B364-65AD14726A23}" type="datetimeFigureOut">
               <a:rPr lang="en-GB" smtClean="0"/>
-              <a:t>21/07/2022</a:t>
+              <a:t>08/08/2022</a:t>
             </a:fld>
             <a:endParaRPr lang="en-GB"/>
           </a:p>
@@ -3048,7 +3140,7 @@
           <a:p>
             <a:fld id="{CC29EC85-173F-467E-B364-65AD14726A23}" type="datetimeFigureOut">
               <a:rPr lang="en-GB" smtClean="0"/>
-              <a:t>21/07/2022</a:t>
+              <a:t>08/08/2022</a:t>
             </a:fld>
             <a:endParaRPr lang="en-GB"/>
           </a:p>
@@ -3260,7 +3352,7 @@
             <a:fld id="{CC29EC85-173F-467E-B364-65AD14726A23}" type="datetimeFigureOut">
               <a:rPr lang="en-GB" smtClean="0"/>
               <a:pPr/>
-              <a:t>21/07/2022</a:t>
+              <a:t>08/08/2022</a:t>
             </a:fld>
             <a:endParaRPr lang="en-GB"/>
           </a:p>
@@ -5045,7 +5137,7 @@
             <a:effectLst/>
             <a:extLst>
               <a:ext uri="{AF507438-7753-43e0-B8FC-AC1667EBCBE1}">
-                <a14:hiddenEffects xmlns="" xmlns:a14="http://schemas.microsoft.com/office/drawing/2010/main">
+                <a14:hiddenEffects xmlns:a14="http://schemas.microsoft.com/office/drawing/2010/main" xmlns="">
                   <a:effectLst>
                     <a:outerShdw dist="35921" dir="2700000" algn="ctr" rotWithShape="0">
                       <a:schemeClr val="bg2"/>
@@ -5107,7 +5199,7 @@
             <a:effectLst/>
             <a:extLst>
               <a:ext uri="{AF507438-7753-43e0-B8FC-AC1667EBCBE1}">
-                <a14:hiddenEffects xmlns="" xmlns:a14="http://schemas.microsoft.com/office/drawing/2010/main">
+                <a14:hiddenEffects xmlns:a14="http://schemas.microsoft.com/office/drawing/2010/main" xmlns="">
                   <a:effectLst>
                     <a:outerShdw dist="35921" dir="2700000" algn="ctr" rotWithShape="0">
                       <a:schemeClr val="bg2"/>
@@ -5169,7 +5261,7 @@
             <a:effectLst/>
             <a:extLst>
               <a:ext uri="{AF507438-7753-43e0-B8FC-AC1667EBCBE1}">
-                <a14:hiddenEffects xmlns="" xmlns:a14="http://schemas.microsoft.com/office/drawing/2010/main">
+                <a14:hiddenEffects xmlns:a14="http://schemas.microsoft.com/office/drawing/2010/main" xmlns="">
                   <a:effectLst>
                     <a:outerShdw dist="35921" dir="2700000" algn="ctr" rotWithShape="0">
                       <a:schemeClr val="bg2"/>
@@ -5375,7 +5467,7 @@
           <a:effectLst/>
           <a:extLst>
             <a:ext uri="{AF507438-7753-43e0-B8FC-AC1667EBCBE1}">
-              <a14:hiddenEffects xmlns="" xmlns:a14="http://schemas.microsoft.com/office/drawing/2010/main">
+              <a14:hiddenEffects xmlns:a14="http://schemas.microsoft.com/office/drawing/2010/main" xmlns="">
                 <a:effectLst>
                   <a:outerShdw dist="35921" dir="2700000" algn="ctr" rotWithShape="0">
                     <a:schemeClr val="bg2"/>
@@ -5706,7 +5798,7 @@
             <a:effectLst/>
             <a:extLst>
               <a:ext uri="{AF507438-7753-43e0-B8FC-AC1667EBCBE1}">
-                <a14:hiddenEffects xmlns="" xmlns:a14="http://schemas.microsoft.com/office/drawing/2010/main">
+                <a14:hiddenEffects xmlns:a14="http://schemas.microsoft.com/office/drawing/2010/main" xmlns="">
                   <a:effectLst>
                     <a:outerShdw dist="35921" dir="2700000" algn="ctr" rotWithShape="0">
                       <a:schemeClr val="bg2"/>
@@ -5768,7 +5860,7 @@
             <a:effectLst/>
             <a:extLst>
               <a:ext uri="{AF507438-7753-43e0-B8FC-AC1667EBCBE1}">
-                <a14:hiddenEffects xmlns="" xmlns:a14="http://schemas.microsoft.com/office/drawing/2010/main">
+                <a14:hiddenEffects xmlns:a14="http://schemas.microsoft.com/office/drawing/2010/main" xmlns="">
                   <a:effectLst>
                     <a:outerShdw dist="35921" dir="2700000" algn="ctr" rotWithShape="0">
                       <a:schemeClr val="bg2"/>
@@ -5845,7 +5937,7 @@
             <a:effectLst/>
             <a:extLst>
               <a:ext uri="{AF507438-7753-43e0-B8FC-AC1667EBCBE1}">
-                <a14:hiddenEffects xmlns="" xmlns:a14="http://schemas.microsoft.com/office/drawing/2010/main">
+                <a14:hiddenEffects xmlns:a14="http://schemas.microsoft.com/office/drawing/2010/main" xmlns="">
                   <a:effectLst>
                     <a:outerShdw dist="35921" dir="2700000" algn="ctr" rotWithShape="0">
                       <a:schemeClr val="bg2"/>
@@ -5907,7 +5999,7 @@
             <a:effectLst/>
             <a:extLst>
               <a:ext uri="{AF507438-7753-43e0-B8FC-AC1667EBCBE1}">
-                <a14:hiddenEffects xmlns="" xmlns:a14="http://schemas.microsoft.com/office/drawing/2010/main">
+                <a14:hiddenEffects xmlns:a14="http://schemas.microsoft.com/office/drawing/2010/main" xmlns="">
                   <a:effectLst>
                     <a:outerShdw dist="35921" dir="2700000" algn="ctr" rotWithShape="0">
                       <a:schemeClr val="bg2"/>
@@ -7140,7 +7232,7 @@
           <a:effectLst/>
           <a:extLst>
             <a:ext uri="{AF507438-7753-43e0-B8FC-AC1667EBCBE1}">
-              <a14:hiddenEffects xmlns="" xmlns:a14="http://schemas.microsoft.com/office/drawing/2010/main">
+              <a14:hiddenEffects xmlns:a14="http://schemas.microsoft.com/office/drawing/2010/main" xmlns="">
                 <a:effectLst>
                   <a:outerShdw dist="35921" dir="2700000" algn="ctr" rotWithShape="0">
                     <a:schemeClr val="bg2"/>
@@ -9647,8 +9739,8 @@
           <a:lstStyle/>
           <a:p>
             <a:r>
-              <a:rPr lang="en-GB" dirty="0" smtClean="0"/>
-              <a:t>Hit by bus</a:t>
+              <a:rPr lang="en-GB" smtClean="0"/>
+              <a:t>Exercise – lottery winner</a:t>
             </a:r>
             <a:endParaRPr lang="en-GB" dirty="0"/>
           </a:p>
@@ -9682,6 +9774,48 @@
           </a:p>
         </p:txBody>
       </p:sp>
+      <p:pic>
+        <p:nvPicPr>
+          <p:cNvPr id="4" name="Picture 3" descr="Top 5 Biggest Lottery Wins Ever"/>
+          <p:cNvPicPr>
+            <a:picLocks noChangeAspect="1"/>
+          </p:cNvPicPr>
+          <p:nvPr/>
+        </p:nvPicPr>
+        <p:blipFill>
+          <a:blip r:embed="rId3">
+            <a:extLst>
+              <a:ext uri="{28A0092B-C50C-407E-A947-70E740481C1C}">
+                <a14:useLocalDpi xmlns:a14="http://schemas.microsoft.com/office/drawing/2010/main" val="0"/>
+              </a:ext>
+            </a:extLst>
+          </a:blip>
+          <a:stretch>
+            <a:fillRect/>
+          </a:stretch>
+        </p:blipFill>
+        <p:spPr>
+          <a:xfrm>
+            <a:off x="3075709" y="1825625"/>
+            <a:ext cx="5807363" cy="4227760"/>
+          </a:xfrm>
+          <a:prstGeom prst="rect">
+            <a:avLst/>
+          </a:prstGeom>
+          <a:ln w="228600" cap="sq" cmpd="thickThin">
+            <a:solidFill>
+              <a:srgbClr val="000000"/>
+            </a:solidFill>
+            <a:prstDash val="solid"/>
+            <a:miter lim="800000"/>
+          </a:ln>
+          <a:effectLst>
+            <a:innerShdw blurRad="76200">
+              <a:srgbClr val="000000"/>
+            </a:innerShdw>
+          </a:effectLst>
+        </p:spPr>
+      </p:pic>
     </p:spTree>
     <p:extLst>
       <p:ext uri="{BB962C8B-B14F-4D97-AF65-F5344CB8AC3E}">
@@ -9735,8 +9869,8 @@
           <a:lstStyle/>
           <a:p>
             <a:r>
-              <a:rPr lang="en-GB" dirty="0" smtClean="0"/>
-              <a:t>Hit by bus</a:t>
+              <a:rPr lang="en-GB" smtClean="0"/>
+              <a:t>Lottery winner exercise - conclusions</a:t>
             </a:r>
             <a:endParaRPr lang="en-GB" dirty="0"/>
           </a:p>
@@ -11163,7 +11297,7 @@
                 <a14:useLocalDpi xmlns:a14="http://schemas.microsoft.com/office/drawing/2010/main" val="0"/>
               </a:ext>
               <a:ext uri="{96DAC541-7B7A-43D3-8B79-37D633B846F1}">
-                <asvg:svgBlip xmlns="" xmlns:asvg="http://schemas.microsoft.com/office/drawing/2016/SVG/main" r:embed="rId3"/>
+                <asvg:svgBlip xmlns:asvg="http://schemas.microsoft.com/office/drawing/2016/SVG/main" xmlns="" r:embed="rId3"/>
               </a:ext>
             </a:extLst>
           </a:blip>
@@ -11202,7 +11336,7 @@
                 <a14:useLocalDpi xmlns:a14="http://schemas.microsoft.com/office/drawing/2010/main" val="0"/>
               </a:ext>
               <a:ext uri="{96DAC541-7B7A-43D3-8B79-37D633B846F1}">
-                <asvg:svgBlip xmlns="" xmlns:asvg="http://schemas.microsoft.com/office/drawing/2016/SVG/main" r:embed="rId5"/>
+                <asvg:svgBlip xmlns:asvg="http://schemas.microsoft.com/office/drawing/2016/SVG/main" xmlns="" r:embed="rId5"/>
               </a:ext>
             </a:extLst>
           </a:blip>
@@ -11241,7 +11375,7 @@
                 <a14:useLocalDpi xmlns:a14="http://schemas.microsoft.com/office/drawing/2010/main" val="0"/>
               </a:ext>
               <a:ext uri="{96DAC541-7B7A-43D3-8B79-37D633B846F1}">
-                <asvg:svgBlip xmlns="" xmlns:asvg="http://schemas.microsoft.com/office/drawing/2016/SVG/main" r:embed="rId7"/>
+                <asvg:svgBlip xmlns:asvg="http://schemas.microsoft.com/office/drawing/2016/SVG/main" xmlns="" r:embed="rId7"/>
               </a:ext>
             </a:extLst>
           </a:blip>
@@ -11280,7 +11414,7 @@
                 <a14:useLocalDpi xmlns:a14="http://schemas.microsoft.com/office/drawing/2010/main" val="0"/>
               </a:ext>
               <a:ext uri="{96DAC541-7B7A-43D3-8B79-37D633B846F1}">
-                <asvg:svgBlip xmlns="" xmlns:asvg="http://schemas.microsoft.com/office/drawing/2016/SVG/main" r:embed="rId9"/>
+                <asvg:svgBlip xmlns:asvg="http://schemas.microsoft.com/office/drawing/2016/SVG/main" xmlns="" r:embed="rId9"/>
               </a:ext>
             </a:extLst>
           </a:blip>
@@ -11319,7 +11453,7 @@
                 <a14:useLocalDpi xmlns:a14="http://schemas.microsoft.com/office/drawing/2010/main" val="0"/>
               </a:ext>
               <a:ext uri="{96DAC541-7B7A-43D3-8B79-37D633B846F1}">
-                <asvg:svgBlip xmlns="" xmlns:asvg="http://schemas.microsoft.com/office/drawing/2016/SVG/main" r:embed="rId11"/>
+                <asvg:svgBlip xmlns:asvg="http://schemas.microsoft.com/office/drawing/2016/SVG/main" xmlns="" r:embed="rId11"/>
               </a:ext>
             </a:extLst>
           </a:blip>
@@ -11358,7 +11492,7 @@
                 <a14:useLocalDpi xmlns:a14="http://schemas.microsoft.com/office/drawing/2010/main" val="0"/>
               </a:ext>
               <a:ext uri="{96DAC541-7B7A-43D3-8B79-37D633B846F1}">
-                <asvg:svgBlip xmlns="" xmlns:asvg="http://schemas.microsoft.com/office/drawing/2016/SVG/main" r:embed="rId13"/>
+                <asvg:svgBlip xmlns:asvg="http://schemas.microsoft.com/office/drawing/2016/SVG/main" xmlns="" r:embed="rId13"/>
               </a:ext>
             </a:extLst>
           </a:blip>
@@ -11722,7 +11856,7 @@
                 <a14:useLocalDpi xmlns:a14="http://schemas.microsoft.com/office/drawing/2010/main" val="0"/>
               </a:ext>
               <a:ext uri="{96DAC541-7B7A-43D3-8B79-37D633B846F1}">
-                <asvg:svgBlip xmlns="" xmlns:asvg="http://schemas.microsoft.com/office/drawing/2016/SVG/main" r:embed="rId3"/>
+                <asvg:svgBlip xmlns:asvg="http://schemas.microsoft.com/office/drawing/2016/SVG/main" xmlns="" r:embed="rId3"/>
               </a:ext>
             </a:extLst>
           </a:blip>
@@ -11937,7 +12071,7 @@
                 <a14:useLocalDpi xmlns:a14="http://schemas.microsoft.com/office/drawing/2010/main" val="0"/>
               </a:ext>
               <a:ext uri="{96DAC541-7B7A-43D3-8B79-37D633B846F1}">
-                <asvg:svgBlip xmlns="" xmlns:asvg="http://schemas.microsoft.com/office/drawing/2016/SVG/main" r:embed="rId3"/>
+                <asvg:svgBlip xmlns:asvg="http://schemas.microsoft.com/office/drawing/2016/SVG/main" xmlns="" r:embed="rId3"/>
               </a:ext>
             </a:extLst>
           </a:blip>

</xml_diff>

<commit_message>
Added link to etherpad on powerpoint prezs, each first slide
</commit_message>
<xml_diff>
--- a/instructors/01-Why_are_we_here.pptx
+++ b/instructors/01-Why_are_we_here.pptx
@@ -220,7 +220,7 @@
           <a:p>
             <a:fld id="{B1D4AFAA-5545-4348-866E-082827204B28}" type="datetimeFigureOut">
               <a:rPr lang="en-GB" smtClean="0"/>
-              <a:t>08/08/2022</a:t>
+              <a:t>22/08/2022</a:t>
             </a:fld>
             <a:endParaRPr lang="en-GB"/>
           </a:p>
@@ -792,7 +792,7 @@
           <a:p>
             <a:fld id="{CC29EC85-173F-467E-B364-65AD14726A23}" type="datetimeFigureOut">
               <a:rPr lang="en-GB" smtClean="0"/>
-              <a:t>08/08/2022</a:t>
+              <a:t>22/08/2022</a:t>
             </a:fld>
             <a:endParaRPr lang="en-GB"/>
           </a:p>
@@ -1009,7 +1009,7 @@
           <a:p>
             <a:fld id="{CC29EC85-173F-467E-B364-65AD14726A23}" type="datetimeFigureOut">
               <a:rPr lang="en-GB" smtClean="0"/>
-              <a:t>08/08/2022</a:t>
+              <a:t>22/08/2022</a:t>
             </a:fld>
             <a:endParaRPr lang="en-GB"/>
           </a:p>
@@ -1189,7 +1189,7 @@
           <a:p>
             <a:fld id="{CC29EC85-173F-467E-B364-65AD14726A23}" type="datetimeFigureOut">
               <a:rPr lang="en-GB" smtClean="0"/>
-              <a:t>08/08/2022</a:t>
+              <a:t>22/08/2022</a:t>
             </a:fld>
             <a:endParaRPr lang="en-GB"/>
           </a:p>
@@ -1552,7 +1552,7 @@
           <a:p>
             <a:fld id="{CC29EC85-173F-467E-B364-65AD14726A23}" type="datetimeFigureOut">
               <a:rPr lang="en-GB" smtClean="0"/>
-              <a:t>08/08/2022</a:t>
+              <a:t>22/08/2022</a:t>
             </a:fld>
             <a:endParaRPr lang="en-GB"/>
           </a:p>
@@ -1798,7 +1798,7 @@
           <a:p>
             <a:fld id="{CC29EC85-173F-467E-B364-65AD14726A23}" type="datetimeFigureOut">
               <a:rPr lang="en-GB" smtClean="0"/>
-              <a:t>08/08/2022</a:t>
+              <a:t>22/08/2022</a:t>
             </a:fld>
             <a:endParaRPr lang="en-GB"/>
           </a:p>
@@ -2030,7 +2030,7 @@
           <a:p>
             <a:fld id="{CC29EC85-173F-467E-B364-65AD14726A23}" type="datetimeFigureOut">
               <a:rPr lang="en-GB" smtClean="0"/>
-              <a:t>08/08/2022</a:t>
+              <a:t>22/08/2022</a:t>
             </a:fld>
             <a:endParaRPr lang="en-GB"/>
           </a:p>
@@ -2397,7 +2397,7 @@
           <a:p>
             <a:fld id="{CC29EC85-173F-467E-B364-65AD14726A23}" type="datetimeFigureOut">
               <a:rPr lang="en-GB" smtClean="0"/>
-              <a:t>08/08/2022</a:t>
+              <a:t>22/08/2022</a:t>
             </a:fld>
             <a:endParaRPr lang="en-GB"/>
           </a:p>
@@ -2515,7 +2515,7 @@
           <a:p>
             <a:fld id="{CC29EC85-173F-467E-B364-65AD14726A23}" type="datetimeFigureOut">
               <a:rPr lang="en-GB" smtClean="0"/>
-              <a:t>08/08/2022</a:t>
+              <a:t>22/08/2022</a:t>
             </a:fld>
             <a:endParaRPr lang="en-GB"/>
           </a:p>
@@ -2610,7 +2610,7 @@
           <a:p>
             <a:fld id="{CC29EC85-173F-467E-B364-65AD14726A23}" type="datetimeFigureOut">
               <a:rPr lang="en-GB" smtClean="0"/>
-              <a:t>08/08/2022</a:t>
+              <a:t>22/08/2022</a:t>
             </a:fld>
             <a:endParaRPr lang="en-GB"/>
           </a:p>
@@ -2887,7 +2887,7 @@
           <a:p>
             <a:fld id="{CC29EC85-173F-467E-B364-65AD14726A23}" type="datetimeFigureOut">
               <a:rPr lang="en-GB" smtClean="0"/>
-              <a:t>08/08/2022</a:t>
+              <a:t>22/08/2022</a:t>
             </a:fld>
             <a:endParaRPr lang="en-GB"/>
           </a:p>
@@ -3140,7 +3140,7 @@
           <a:p>
             <a:fld id="{CC29EC85-173F-467E-B364-65AD14726A23}" type="datetimeFigureOut">
               <a:rPr lang="en-GB" smtClean="0"/>
-              <a:t>08/08/2022</a:t>
+              <a:t>22/08/2022</a:t>
             </a:fld>
             <a:endParaRPr lang="en-GB"/>
           </a:p>
@@ -3352,7 +3352,7 @@
             <a:fld id="{CC29EC85-173F-467E-B364-65AD14726A23}" type="datetimeFigureOut">
               <a:rPr lang="en-GB" smtClean="0"/>
               <a:pPr/>
-              <a:t>08/08/2022</a:t>
+              <a:t>22/08/2022</a:t>
             </a:fld>
             <a:endParaRPr lang="en-GB"/>
           </a:p>
@@ -3844,6 +3844,117 @@
           </a:p>
         </p:txBody>
       </p:sp>
+      <p:grpSp>
+        <p:nvGrpSpPr>
+          <p:cNvPr id="6" name="Group 5"/>
+          <p:cNvGrpSpPr/>
+          <p:nvPr/>
+        </p:nvGrpSpPr>
+        <p:grpSpPr>
+          <a:xfrm>
+            <a:off x="335498" y="5785681"/>
+            <a:ext cx="7747345" cy="469783"/>
+            <a:chOff x="335498" y="5785681"/>
+            <a:chExt cx="7747345" cy="469783"/>
+          </a:xfrm>
+        </p:grpSpPr>
+        <p:sp>
+          <p:nvSpPr>
+            <p:cNvPr id="7" name="TextBox 6">
+              <a:extLst>
+                <a:ext uri="{FF2B5EF4-FFF2-40B4-BE49-F238E27FC236}">
+                  <a16:creationId xmlns:a16="http://schemas.microsoft.com/office/drawing/2014/main" id="{441D6036-BCDA-4EC7-9653-F205FE226493}"/>
+                </a:ext>
+              </a:extLst>
+            </p:cNvPr>
+            <p:cNvSpPr txBox="1"/>
+            <p:nvPr/>
+          </p:nvSpPr>
+          <p:spPr>
+            <a:xfrm>
+              <a:off x="1092764" y="5835907"/>
+              <a:ext cx="6990079" cy="369332"/>
+            </a:xfrm>
+            <a:prstGeom prst="rect">
+              <a:avLst/>
+            </a:prstGeom>
+            <a:noFill/>
+          </p:spPr>
+          <p:txBody>
+            <a:bodyPr wrap="square">
+              <a:spAutoFit/>
+            </a:bodyPr>
+            <a:lstStyle/>
+            <a:p>
+              <a:r>
+                <a:rPr lang="en-GB"/>
+                <a:t>Open </a:t>
+              </a:r>
+              <a:r>
+                <a:rPr lang="en-GB" smtClean="0">
+                  <a:hlinkClick r:id="rId2"/>
+                </a:rPr>
+                <a:t>https://pad.carpentries.org/fair-4-leaders-begins-20YY-MM-DD</a:t>
+              </a:r>
+              <a:r>
+                <a:rPr lang="en-GB" smtClean="0"/>
+                <a:t>  </a:t>
+              </a:r>
+              <a:endParaRPr lang="en-GB" dirty="0">
+                <a:highlight>
+                  <a:srgbClr val="FFFF00"/>
+                </a:highlight>
+              </a:endParaRPr>
+            </a:p>
+          </p:txBody>
+        </p:sp>
+        <p:sp>
+          <p:nvSpPr>
+            <p:cNvPr id="8" name="Arrow: Down 7">
+              <a:extLst>
+                <a:ext uri="{FF2B5EF4-FFF2-40B4-BE49-F238E27FC236}">
+                  <a16:creationId xmlns:a16="http://schemas.microsoft.com/office/drawing/2014/main" id="{490697C4-1D52-44B3-9145-1E4126021820}"/>
+                </a:ext>
+              </a:extLst>
+            </p:cNvPr>
+            <p:cNvSpPr/>
+            <p:nvPr/>
+          </p:nvSpPr>
+          <p:spPr>
+            <a:xfrm rot="16200000">
+              <a:off x="410999" y="5710180"/>
+              <a:ext cx="469783" cy="620786"/>
+            </a:xfrm>
+            <a:prstGeom prst="downArrow">
+              <a:avLst/>
+            </a:prstGeom>
+          </p:spPr>
+          <p:style>
+            <a:lnRef idx="2">
+              <a:schemeClr val="accent1">
+                <a:shade val="50000"/>
+              </a:schemeClr>
+            </a:lnRef>
+            <a:fillRef idx="1">
+              <a:schemeClr val="accent1"/>
+            </a:fillRef>
+            <a:effectRef idx="0">
+              <a:schemeClr val="accent1"/>
+            </a:effectRef>
+            <a:fontRef idx="minor">
+              <a:schemeClr val="lt1"/>
+            </a:fontRef>
+          </p:style>
+          <p:txBody>
+            <a:bodyPr rtlCol="0" anchor="ctr"/>
+            <a:lstStyle/>
+            <a:p>
+              <a:pPr algn="ctr"/>
+              <a:endParaRPr lang="en-GB" dirty="0"/>
+            </a:p>
+          </p:txBody>
+        </p:sp>
+      </p:grpSp>
     </p:spTree>
     <p:extLst>
       <p:ext uri="{BB962C8B-B14F-4D97-AF65-F5344CB8AC3E}">
@@ -5137,7 +5248,7 @@
             <a:effectLst/>
             <a:extLst>
               <a:ext uri="{AF507438-7753-43e0-B8FC-AC1667EBCBE1}">
-                <a14:hiddenEffects xmlns:a14="http://schemas.microsoft.com/office/drawing/2010/main" xmlns="">
+                <a14:hiddenEffects xmlns="" xmlns:a14="http://schemas.microsoft.com/office/drawing/2010/main">
                   <a:effectLst>
                     <a:outerShdw dist="35921" dir="2700000" algn="ctr" rotWithShape="0">
                       <a:schemeClr val="bg2"/>
@@ -5199,7 +5310,7 @@
             <a:effectLst/>
             <a:extLst>
               <a:ext uri="{AF507438-7753-43e0-B8FC-AC1667EBCBE1}">
-                <a14:hiddenEffects xmlns:a14="http://schemas.microsoft.com/office/drawing/2010/main" xmlns="">
+                <a14:hiddenEffects xmlns="" xmlns:a14="http://schemas.microsoft.com/office/drawing/2010/main">
                   <a:effectLst>
                     <a:outerShdw dist="35921" dir="2700000" algn="ctr" rotWithShape="0">
                       <a:schemeClr val="bg2"/>
@@ -5261,7 +5372,7 @@
             <a:effectLst/>
             <a:extLst>
               <a:ext uri="{AF507438-7753-43e0-B8FC-AC1667EBCBE1}">
-                <a14:hiddenEffects xmlns:a14="http://schemas.microsoft.com/office/drawing/2010/main" xmlns="">
+                <a14:hiddenEffects xmlns="" xmlns:a14="http://schemas.microsoft.com/office/drawing/2010/main">
                   <a:effectLst>
                     <a:outerShdw dist="35921" dir="2700000" algn="ctr" rotWithShape="0">
                       <a:schemeClr val="bg2"/>
@@ -5467,7 +5578,7 @@
           <a:effectLst/>
           <a:extLst>
             <a:ext uri="{AF507438-7753-43e0-B8FC-AC1667EBCBE1}">
-              <a14:hiddenEffects xmlns:a14="http://schemas.microsoft.com/office/drawing/2010/main" xmlns="">
+              <a14:hiddenEffects xmlns="" xmlns:a14="http://schemas.microsoft.com/office/drawing/2010/main">
                 <a:effectLst>
                   <a:outerShdw dist="35921" dir="2700000" algn="ctr" rotWithShape="0">
                     <a:schemeClr val="bg2"/>
@@ -5798,7 +5909,7 @@
             <a:effectLst/>
             <a:extLst>
               <a:ext uri="{AF507438-7753-43e0-B8FC-AC1667EBCBE1}">
-                <a14:hiddenEffects xmlns:a14="http://schemas.microsoft.com/office/drawing/2010/main" xmlns="">
+                <a14:hiddenEffects xmlns="" xmlns:a14="http://schemas.microsoft.com/office/drawing/2010/main">
                   <a:effectLst>
                     <a:outerShdw dist="35921" dir="2700000" algn="ctr" rotWithShape="0">
                       <a:schemeClr val="bg2"/>
@@ -5860,7 +5971,7 @@
             <a:effectLst/>
             <a:extLst>
               <a:ext uri="{AF507438-7753-43e0-B8FC-AC1667EBCBE1}">
-                <a14:hiddenEffects xmlns:a14="http://schemas.microsoft.com/office/drawing/2010/main" xmlns="">
+                <a14:hiddenEffects xmlns="" xmlns:a14="http://schemas.microsoft.com/office/drawing/2010/main">
                   <a:effectLst>
                     <a:outerShdw dist="35921" dir="2700000" algn="ctr" rotWithShape="0">
                       <a:schemeClr val="bg2"/>
@@ -5937,7 +6048,7 @@
             <a:effectLst/>
             <a:extLst>
               <a:ext uri="{AF507438-7753-43e0-B8FC-AC1667EBCBE1}">
-                <a14:hiddenEffects xmlns:a14="http://schemas.microsoft.com/office/drawing/2010/main" xmlns="">
+                <a14:hiddenEffects xmlns="" xmlns:a14="http://schemas.microsoft.com/office/drawing/2010/main">
                   <a:effectLst>
                     <a:outerShdw dist="35921" dir="2700000" algn="ctr" rotWithShape="0">
                       <a:schemeClr val="bg2"/>
@@ -5999,7 +6110,7 @@
             <a:effectLst/>
             <a:extLst>
               <a:ext uri="{AF507438-7753-43e0-B8FC-AC1667EBCBE1}">
-                <a14:hiddenEffects xmlns:a14="http://schemas.microsoft.com/office/drawing/2010/main" xmlns="">
+                <a14:hiddenEffects xmlns="" xmlns:a14="http://schemas.microsoft.com/office/drawing/2010/main">
                   <a:effectLst>
                     <a:outerShdw dist="35921" dir="2700000" algn="ctr" rotWithShape="0">
                       <a:schemeClr val="bg2"/>
@@ -7232,7 +7343,7 @@
           <a:effectLst/>
           <a:extLst>
             <a:ext uri="{AF507438-7753-43e0-B8FC-AC1667EBCBE1}">
-              <a14:hiddenEffects xmlns:a14="http://schemas.microsoft.com/office/drawing/2010/main" xmlns="">
+              <a14:hiddenEffects xmlns="" xmlns:a14="http://schemas.microsoft.com/office/drawing/2010/main">
                 <a:effectLst>
                   <a:outerShdw dist="35921" dir="2700000" algn="ctr" rotWithShape="0">
                     <a:schemeClr val="bg2"/>
@@ -11297,7 +11408,7 @@
                 <a14:useLocalDpi xmlns:a14="http://schemas.microsoft.com/office/drawing/2010/main" val="0"/>
               </a:ext>
               <a:ext uri="{96DAC541-7B7A-43D3-8B79-37D633B846F1}">
-                <asvg:svgBlip xmlns:asvg="http://schemas.microsoft.com/office/drawing/2016/SVG/main" xmlns="" r:embed="rId3"/>
+                <asvg:svgBlip xmlns="" xmlns:asvg="http://schemas.microsoft.com/office/drawing/2016/SVG/main" r:embed="rId3"/>
               </a:ext>
             </a:extLst>
           </a:blip>
@@ -11336,7 +11447,7 @@
                 <a14:useLocalDpi xmlns:a14="http://schemas.microsoft.com/office/drawing/2010/main" val="0"/>
               </a:ext>
               <a:ext uri="{96DAC541-7B7A-43D3-8B79-37D633B846F1}">
-                <asvg:svgBlip xmlns:asvg="http://schemas.microsoft.com/office/drawing/2016/SVG/main" xmlns="" r:embed="rId5"/>
+                <asvg:svgBlip xmlns="" xmlns:asvg="http://schemas.microsoft.com/office/drawing/2016/SVG/main" r:embed="rId5"/>
               </a:ext>
             </a:extLst>
           </a:blip>
@@ -11375,7 +11486,7 @@
                 <a14:useLocalDpi xmlns:a14="http://schemas.microsoft.com/office/drawing/2010/main" val="0"/>
               </a:ext>
               <a:ext uri="{96DAC541-7B7A-43D3-8B79-37D633B846F1}">
-                <asvg:svgBlip xmlns:asvg="http://schemas.microsoft.com/office/drawing/2016/SVG/main" xmlns="" r:embed="rId7"/>
+                <asvg:svgBlip xmlns="" xmlns:asvg="http://schemas.microsoft.com/office/drawing/2016/SVG/main" r:embed="rId7"/>
               </a:ext>
             </a:extLst>
           </a:blip>
@@ -11414,7 +11525,7 @@
                 <a14:useLocalDpi xmlns:a14="http://schemas.microsoft.com/office/drawing/2010/main" val="0"/>
               </a:ext>
               <a:ext uri="{96DAC541-7B7A-43D3-8B79-37D633B846F1}">
-                <asvg:svgBlip xmlns:asvg="http://schemas.microsoft.com/office/drawing/2016/SVG/main" xmlns="" r:embed="rId9"/>
+                <asvg:svgBlip xmlns="" xmlns:asvg="http://schemas.microsoft.com/office/drawing/2016/SVG/main" r:embed="rId9"/>
               </a:ext>
             </a:extLst>
           </a:blip>
@@ -11453,7 +11564,7 @@
                 <a14:useLocalDpi xmlns:a14="http://schemas.microsoft.com/office/drawing/2010/main" val="0"/>
               </a:ext>
               <a:ext uri="{96DAC541-7B7A-43D3-8B79-37D633B846F1}">
-                <asvg:svgBlip xmlns:asvg="http://schemas.microsoft.com/office/drawing/2016/SVG/main" xmlns="" r:embed="rId11"/>
+                <asvg:svgBlip xmlns="" xmlns:asvg="http://schemas.microsoft.com/office/drawing/2016/SVG/main" r:embed="rId11"/>
               </a:ext>
             </a:extLst>
           </a:blip>
@@ -11492,7 +11603,7 @@
                 <a14:useLocalDpi xmlns:a14="http://schemas.microsoft.com/office/drawing/2010/main" val="0"/>
               </a:ext>
               <a:ext uri="{96DAC541-7B7A-43D3-8B79-37D633B846F1}">
-                <asvg:svgBlip xmlns:asvg="http://schemas.microsoft.com/office/drawing/2016/SVG/main" xmlns="" r:embed="rId13"/>
+                <asvg:svgBlip xmlns="" xmlns:asvg="http://schemas.microsoft.com/office/drawing/2016/SVG/main" r:embed="rId13"/>
               </a:ext>
             </a:extLst>
           </a:blip>
@@ -11856,7 +11967,7 @@
                 <a14:useLocalDpi xmlns:a14="http://schemas.microsoft.com/office/drawing/2010/main" val="0"/>
               </a:ext>
               <a:ext uri="{96DAC541-7B7A-43D3-8B79-37D633B846F1}">
-                <asvg:svgBlip xmlns:asvg="http://schemas.microsoft.com/office/drawing/2016/SVG/main" xmlns="" r:embed="rId3"/>
+                <asvg:svgBlip xmlns="" xmlns:asvg="http://schemas.microsoft.com/office/drawing/2016/SVG/main" r:embed="rId3"/>
               </a:ext>
             </a:extLst>
           </a:blip>
@@ -12071,7 +12182,7 @@
                 <a14:useLocalDpi xmlns:a14="http://schemas.microsoft.com/office/drawing/2010/main" val="0"/>
               </a:ext>
               <a:ext uri="{96DAC541-7B7A-43D3-8B79-37D633B846F1}">
-                <asvg:svgBlip xmlns:asvg="http://schemas.microsoft.com/office/drawing/2016/SVG/main" xmlns="" r:embed="rId3"/>
+                <asvg:svgBlip xmlns="" xmlns:asvg="http://schemas.microsoft.com/office/drawing/2016/SVG/main" r:embed="rId3"/>
               </a:ext>
             </a:extLst>
           </a:blip>

</xml_diff>

<commit_message>
Tools for olverlords revised
</commit_message>
<xml_diff>
--- a/instructors/01-Why_are_we_here.pptx
+++ b/instructors/01-Why_are_we_here.pptx
@@ -3847,117 +3847,42 @@
           </a:p>
         </p:txBody>
       </p:sp>
-      <p:grpSp>
-        <p:nvGrpSpPr>
-          <p:cNvPr id="6" name="Group 5"/>
-          <p:cNvGrpSpPr/>
+      <p:sp>
+        <p:nvSpPr>
+          <p:cNvPr id="7" name="TextBox 6">
+            <a:extLst>
+              <a:ext uri="{FF2B5EF4-FFF2-40B4-BE49-F238E27FC236}">
+                <a16:creationId xmlns:a16="http://schemas.microsoft.com/office/drawing/2014/main" id="{441D6036-BCDA-4EC7-9653-F205FE226493}"/>
+              </a:ext>
+            </a:extLst>
+          </p:cNvPr>
+          <p:cNvSpPr txBox="1"/>
           <p:nvPr/>
-        </p:nvGrpSpPr>
-        <p:grpSpPr>
+        </p:nvSpPr>
+        <p:spPr>
           <a:xfrm>
-            <a:off x="335498" y="5785681"/>
-            <a:ext cx="7747345" cy="469783"/>
-            <a:chOff x="335498" y="5785681"/>
-            <a:chExt cx="7747345" cy="469783"/>
+            <a:off x="1092764" y="5835907"/>
+            <a:ext cx="6990079" cy="369332"/>
           </a:xfrm>
-        </p:grpSpPr>
-        <p:sp>
-          <p:nvSpPr>
-            <p:cNvPr id="7" name="TextBox 6">
-              <a:extLst>
-                <a:ext uri="{FF2B5EF4-FFF2-40B4-BE49-F238E27FC236}">
-                  <a16:creationId xmlns:a16="http://schemas.microsoft.com/office/drawing/2014/main" id="{441D6036-BCDA-4EC7-9653-F205FE226493}"/>
-                </a:ext>
-              </a:extLst>
-            </p:cNvPr>
-            <p:cNvSpPr txBox="1"/>
-            <p:nvPr/>
-          </p:nvSpPr>
-          <p:spPr>
-            <a:xfrm>
-              <a:off x="1092764" y="5835907"/>
-              <a:ext cx="6990079" cy="369332"/>
-            </a:xfrm>
-            <a:prstGeom prst="rect">
-              <a:avLst/>
-            </a:prstGeom>
-            <a:noFill/>
-          </p:spPr>
-          <p:txBody>
-            <a:bodyPr wrap="square">
-              <a:spAutoFit/>
-            </a:bodyPr>
-            <a:lstStyle/>
-            <a:p>
-              <a:r>
-                <a:rPr lang="en-GB"/>
-                <a:t>Open </a:t>
-              </a:r>
-              <a:r>
-                <a:rPr lang="en-GB" smtClean="0">
-                  <a:hlinkClick r:id="rId2"/>
-                </a:rPr>
-                <a:t>https://pad.carpentries.org/fair-4-leaders-begins-20YY-MM-DD</a:t>
-              </a:r>
-              <a:r>
-                <a:rPr lang="en-GB" smtClean="0"/>
-                <a:t>  </a:t>
-              </a:r>
-              <a:endParaRPr lang="en-GB" dirty="0">
-                <a:highlight>
-                  <a:srgbClr val="FFFF00"/>
-                </a:highlight>
-              </a:endParaRPr>
-            </a:p>
-          </p:txBody>
-        </p:sp>
-        <p:sp>
-          <p:nvSpPr>
-            <p:cNvPr id="8" name="Arrow: Down 7">
-              <a:extLst>
-                <a:ext uri="{FF2B5EF4-FFF2-40B4-BE49-F238E27FC236}">
-                  <a16:creationId xmlns:a16="http://schemas.microsoft.com/office/drawing/2014/main" id="{490697C4-1D52-44B3-9145-1E4126021820}"/>
-                </a:ext>
-              </a:extLst>
-            </p:cNvPr>
-            <p:cNvSpPr/>
-            <p:nvPr/>
-          </p:nvSpPr>
-          <p:spPr>
-            <a:xfrm rot="16200000">
-              <a:off x="410999" y="5710180"/>
-              <a:ext cx="469783" cy="620786"/>
-            </a:xfrm>
-            <a:prstGeom prst="downArrow">
-              <a:avLst/>
-            </a:prstGeom>
-          </p:spPr>
-          <p:style>
-            <a:lnRef idx="2">
-              <a:schemeClr val="accent1">
-                <a:shade val="50000"/>
-              </a:schemeClr>
-            </a:lnRef>
-            <a:fillRef idx="1">
-              <a:schemeClr val="accent1"/>
-            </a:fillRef>
-            <a:effectRef idx="0">
-              <a:schemeClr val="accent1"/>
-            </a:effectRef>
-            <a:fontRef idx="minor">
-              <a:schemeClr val="lt1"/>
-            </a:fontRef>
-          </p:style>
-          <p:txBody>
-            <a:bodyPr rtlCol="0" anchor="ctr"/>
-            <a:lstStyle/>
-            <a:p>
-              <a:pPr algn="ctr"/>
-              <a:endParaRPr lang="en-GB" dirty="0"/>
-            </a:p>
-          </p:txBody>
-        </p:sp>
-      </p:grpSp>
+          <a:prstGeom prst="rect">
+            <a:avLst/>
+          </a:prstGeom>
+          <a:noFill/>
+        </p:spPr>
+        <p:txBody>
+          <a:bodyPr wrap="square">
+            <a:spAutoFit/>
+          </a:bodyPr>
+          <a:lstStyle/>
+          <a:p>
+            <a:endParaRPr lang="en-GB" dirty="0">
+              <a:highlight>
+                <a:srgbClr val="FFFF00"/>
+              </a:highlight>
+            </a:endParaRPr>
+          </a:p>
+        </p:txBody>
+      </p:sp>
     </p:spTree>
     <p:extLst>
       <p:ext uri="{BB962C8B-B14F-4D97-AF65-F5344CB8AC3E}">
@@ -4157,7 +4082,7 @@
                 <a14:useLocalDpi xmlns:a14="http://schemas.microsoft.com/office/drawing/2010/main" val="0"/>
               </a:ext>
               <a:ext uri="{96DAC541-7B7A-43D3-8B79-37D633B846F1}">
-                <asvg:svgBlip xmlns="" xmlns:asvg="http://schemas.microsoft.com/office/drawing/2016/SVG/main" r:embed="rId3"/>
+                <asvg:svgBlip xmlns:asvg="http://schemas.microsoft.com/office/drawing/2016/SVG/main" xmlns="" r:embed="rId3"/>
               </a:ext>
             </a:extLst>
           </a:blip>
@@ -4296,7 +4221,7 @@
                 <a14:useLocalDpi xmlns:a14="http://schemas.microsoft.com/office/drawing/2010/main" val="0"/>
               </a:ext>
               <a:ext uri="{96DAC541-7B7A-43D3-8B79-37D633B846F1}">
-                <asvg:svgBlip xmlns:asvg="http://schemas.microsoft.com/office/drawing/2016/SVG/main" xmlns="" r:embed="rId3"/>
+                <asvg:svgBlip xmlns="" xmlns:asvg="http://schemas.microsoft.com/office/drawing/2016/SVG/main" r:embed="rId3"/>
               </a:ext>
             </a:extLst>
           </a:blip>
@@ -4511,7 +4436,7 @@
                 <a14:useLocalDpi xmlns:a14="http://schemas.microsoft.com/office/drawing/2010/main" val="0"/>
               </a:ext>
               <a:ext uri="{96DAC541-7B7A-43D3-8B79-37D633B846F1}">
-                <asvg:svgBlip xmlns:asvg="http://schemas.microsoft.com/office/drawing/2016/SVG/main" xmlns="" r:embed="rId3"/>
+                <asvg:svgBlip xmlns="" xmlns:asvg="http://schemas.microsoft.com/office/drawing/2016/SVG/main" r:embed="rId3"/>
               </a:ext>
             </a:extLst>
           </a:blip>
@@ -5822,7 +5747,7 @@
             <a:effectLst/>
             <a:extLst>
               <a:ext uri="{AF507438-7753-43e0-B8FC-AC1667EBCBE1}">
-                <a14:hiddenEffects xmlns:a14="http://schemas.microsoft.com/office/drawing/2010/main" xmlns="">
+                <a14:hiddenEffects xmlns="" xmlns:a14="http://schemas.microsoft.com/office/drawing/2010/main">
                   <a:effectLst>
                     <a:outerShdw dist="35921" dir="2700000" algn="ctr" rotWithShape="0">
                       <a:schemeClr val="bg2"/>
@@ -5884,7 +5809,7 @@
             <a:effectLst/>
             <a:extLst>
               <a:ext uri="{AF507438-7753-43e0-B8FC-AC1667EBCBE1}">
-                <a14:hiddenEffects xmlns:a14="http://schemas.microsoft.com/office/drawing/2010/main" xmlns="">
+                <a14:hiddenEffects xmlns="" xmlns:a14="http://schemas.microsoft.com/office/drawing/2010/main">
                   <a:effectLst>
                     <a:outerShdw dist="35921" dir="2700000" algn="ctr" rotWithShape="0">
                       <a:schemeClr val="bg2"/>
@@ -5946,7 +5871,7 @@
             <a:effectLst/>
             <a:extLst>
               <a:ext uri="{AF507438-7753-43e0-B8FC-AC1667EBCBE1}">
-                <a14:hiddenEffects xmlns:a14="http://schemas.microsoft.com/office/drawing/2010/main" xmlns="">
+                <a14:hiddenEffects xmlns="" xmlns:a14="http://schemas.microsoft.com/office/drawing/2010/main">
                   <a:effectLst>
                     <a:outerShdw dist="35921" dir="2700000" algn="ctr" rotWithShape="0">
                       <a:schemeClr val="bg2"/>
@@ -6152,7 +6077,7 @@
           <a:effectLst/>
           <a:extLst>
             <a:ext uri="{AF507438-7753-43e0-B8FC-AC1667EBCBE1}">
-              <a14:hiddenEffects xmlns:a14="http://schemas.microsoft.com/office/drawing/2010/main" xmlns="">
+              <a14:hiddenEffects xmlns="" xmlns:a14="http://schemas.microsoft.com/office/drawing/2010/main">
                 <a:effectLst>
                   <a:outerShdw dist="35921" dir="2700000" algn="ctr" rotWithShape="0">
                     <a:schemeClr val="bg2"/>
@@ -6483,7 +6408,7 @@
             <a:effectLst/>
             <a:extLst>
               <a:ext uri="{AF507438-7753-43e0-B8FC-AC1667EBCBE1}">
-                <a14:hiddenEffects xmlns:a14="http://schemas.microsoft.com/office/drawing/2010/main" xmlns="">
+                <a14:hiddenEffects xmlns="" xmlns:a14="http://schemas.microsoft.com/office/drawing/2010/main">
                   <a:effectLst>
                     <a:outerShdw dist="35921" dir="2700000" algn="ctr" rotWithShape="0">
                       <a:schemeClr val="bg2"/>
@@ -6545,7 +6470,7 @@
             <a:effectLst/>
             <a:extLst>
               <a:ext uri="{AF507438-7753-43e0-B8FC-AC1667EBCBE1}">
-                <a14:hiddenEffects xmlns:a14="http://schemas.microsoft.com/office/drawing/2010/main" xmlns="">
+                <a14:hiddenEffects xmlns="" xmlns:a14="http://schemas.microsoft.com/office/drawing/2010/main">
                   <a:effectLst>
                     <a:outerShdw dist="35921" dir="2700000" algn="ctr" rotWithShape="0">
                       <a:schemeClr val="bg2"/>
@@ -6622,7 +6547,7 @@
             <a:effectLst/>
             <a:extLst>
               <a:ext uri="{AF507438-7753-43e0-B8FC-AC1667EBCBE1}">
-                <a14:hiddenEffects xmlns:a14="http://schemas.microsoft.com/office/drawing/2010/main" xmlns="">
+                <a14:hiddenEffects xmlns="" xmlns:a14="http://schemas.microsoft.com/office/drawing/2010/main">
                   <a:effectLst>
                     <a:outerShdw dist="35921" dir="2700000" algn="ctr" rotWithShape="0">
                       <a:schemeClr val="bg2"/>
@@ -6684,7 +6609,7 @@
             <a:effectLst/>
             <a:extLst>
               <a:ext uri="{AF507438-7753-43e0-B8FC-AC1667EBCBE1}">
-                <a14:hiddenEffects xmlns:a14="http://schemas.microsoft.com/office/drawing/2010/main" xmlns="">
+                <a14:hiddenEffects xmlns="" xmlns:a14="http://schemas.microsoft.com/office/drawing/2010/main">
                   <a:effectLst>
                     <a:outerShdw dist="35921" dir="2700000" algn="ctr" rotWithShape="0">
                       <a:schemeClr val="bg2"/>
@@ -7917,7 +7842,7 @@
           <a:effectLst/>
           <a:extLst>
             <a:ext uri="{AF507438-7753-43e0-B8FC-AC1667EBCBE1}">
-              <a14:hiddenEffects xmlns:a14="http://schemas.microsoft.com/office/drawing/2010/main" xmlns="">
+              <a14:hiddenEffects xmlns="" xmlns:a14="http://schemas.microsoft.com/office/drawing/2010/main">
                 <a:effectLst>
                   <a:outerShdw dist="35921" dir="2700000" algn="ctr" rotWithShape="0">
                     <a:schemeClr val="bg2"/>
@@ -10897,22 +10822,16 @@
               <a:rPr lang="pl-PL" sz="1400" dirty="0">
                 <a:hlinkClick r:id="rId2"/>
               </a:rPr>
-              <a:t>https</a:t>
-            </a:r>
-            <a:r>
-              <a:rPr lang="pl-PL" sz="1400">
-                <a:hlinkClick r:id="rId2"/>
-              </a:rPr>
-              <a:t>://</a:t>
-            </a:r>
-            <a:r>
-              <a:rPr lang="pl-PL" sz="1400" smtClean="0">
+              <a:t>https://</a:t>
+            </a:r>
+            <a:r>
+              <a:rPr lang="pl-PL" sz="1400" dirty="0" smtClean="0">
                 <a:hlinkClick r:id="rId2"/>
               </a:rPr>
               <a:t>www.fosteropenscience.eu/content/what-open-science-introduction</a:t>
             </a:r>
             <a:r>
-              <a:rPr lang="en-GB" sz="1400" smtClean="0"/>
+              <a:rPr lang="en-GB" sz="1400" dirty="0" smtClean="0"/>
               <a:t> </a:t>
             </a:r>
             <a:endParaRPr lang="pl-PL" sz="1400" dirty="0"/>
@@ -11050,11 +10969,7 @@
           <a:p>
             <a:r>
               <a:rPr lang="pl-PL" sz="1400" dirty="0" smtClean="0"/>
-              <a:t>[3</a:t>
-            </a:r>
-            <a:r>
-              <a:rPr lang="pl-PL" sz="1400" smtClean="0"/>
-              <a:t>] Photo Jonathunder, Medal</a:t>
+              <a:t>[3] Photo Jonathunder, Medal</a:t>
             </a:r>
             <a:r>
               <a:rPr lang="pl-PL" sz="1400" dirty="0"/>
@@ -11146,31 +11061,25 @@
               <a:rPr lang="pl-PL" sz="1400" dirty="0">
                 <a:hlinkClick r:id="rId8"/>
               </a:rPr>
-              <a:t>https://</a:t>
-            </a:r>
-            <a:r>
-              <a:rPr lang="pl-PL" sz="1400">
-                <a:hlinkClick r:id="rId8"/>
-              </a:rPr>
-              <a:t>sfdora.org/resource/dora-slide-presentations</a:t>
-            </a:r>
-            <a:r>
-              <a:rPr lang="pl-PL" sz="1400" smtClean="0">
+              <a:t>https://sfdora.org/resource/dora-slide-presentations</a:t>
+            </a:r>
+            <a:r>
+              <a:rPr lang="pl-PL" sz="1400" dirty="0" smtClean="0">
                 <a:hlinkClick r:id="rId8"/>
               </a:rPr>
               <a:t>/</a:t>
             </a:r>
-            <a:endParaRPr lang="en-GB" sz="1400" smtClean="0"/>
-          </a:p>
-          <a:p>
-            <a:endParaRPr lang="en-GB" sz="1400"/>
+            <a:endParaRPr lang="en-GB" sz="1400" dirty="0" smtClean="0"/>
+          </a:p>
+          <a:p>
+            <a:endParaRPr lang="en-GB" sz="1400" dirty="0"/>
           </a:p>
           <a:p>
             <a:pPr marL="0" indent="0">
               <a:buNone/>
             </a:pPr>
             <a:r>
-              <a:rPr lang="en-GB" sz="2000" smtClean="0"/>
+              <a:rPr lang="en-GB" sz="2000" dirty="0" smtClean="0"/>
               <a:t>Funding</a:t>
             </a:r>
           </a:p>
@@ -11179,11 +11088,19 @@
               <a:buNone/>
             </a:pPr>
             <a:r>
-              <a:rPr lang="en-GB" sz="1400" smtClean="0"/>
-              <a:t>Ed-DaSH </a:t>
-            </a:r>
-            <a:r>
-              <a:rPr lang="en-GB" sz="1400"/>
+              <a:rPr lang="en-GB" sz="1400" dirty="0" smtClean="0"/>
+              <a:t>Ed-</a:t>
+            </a:r>
+            <a:r>
+              <a:rPr lang="en-GB" sz="1400" dirty="0" err="1" smtClean="0"/>
+              <a:t>DaSH</a:t>
+            </a:r>
+            <a:r>
+              <a:rPr lang="en-GB" sz="1400" dirty="0" smtClean="0"/>
+              <a:t> </a:t>
+            </a:r>
+            <a:r>
+              <a:rPr lang="en-GB" sz="1400" dirty="0"/>
               <a:t>is a Data Science training programme for Health and Biosciences. This work was supported by UK Research and Innovation [grant number MR/V039075/1].</a:t>
             </a:r>
           </a:p>
@@ -11192,25 +11109,25 @@
               <a:buNone/>
             </a:pPr>
             <a:r>
-              <a:rPr lang="en-GB" sz="1400" smtClean="0">
+              <a:rPr lang="en-GB" sz="1400" dirty="0" smtClean="0">
                 <a:hlinkClick r:id="rId9"/>
               </a:rPr>
               <a:t>https</a:t>
             </a:r>
             <a:r>
-              <a:rPr lang="en-GB" sz="1400">
+              <a:rPr lang="en-GB" sz="1400" dirty="0">
                 <a:hlinkClick r:id="rId9"/>
               </a:rPr>
               <a:t>://edcarp.github.io/Ed-DaSH</a:t>
             </a:r>
             <a:r>
-              <a:rPr lang="en-GB" sz="1400" smtClean="0">
+              <a:rPr lang="en-GB" sz="1400" dirty="0" smtClean="0">
                 <a:hlinkClick r:id="rId9"/>
               </a:rPr>
               <a:t>/</a:t>
             </a:r>
             <a:r>
-              <a:rPr lang="en-GB" sz="1400" smtClean="0"/>
+              <a:rPr lang="en-GB" sz="1400" dirty="0" smtClean="0"/>
               <a:t> </a:t>
             </a:r>
             <a:endParaRPr lang="pl-PL" sz="1400" dirty="0" smtClean="0"/>
@@ -11978,7 +11895,7 @@
                 <a14:useLocalDpi xmlns:a14="http://schemas.microsoft.com/office/drawing/2010/main" val="0"/>
               </a:ext>
               <a:ext uri="{96DAC541-7B7A-43D3-8B79-37D633B846F1}">
-                <asvg:svgBlip xmlns:asvg="http://schemas.microsoft.com/office/drawing/2016/SVG/main" xmlns="" r:embed="rId3"/>
+                <asvg:svgBlip xmlns="" xmlns:asvg="http://schemas.microsoft.com/office/drawing/2016/SVG/main" r:embed="rId3"/>
               </a:ext>
             </a:extLst>
           </a:blip>
@@ -12017,7 +11934,7 @@
                 <a14:useLocalDpi xmlns:a14="http://schemas.microsoft.com/office/drawing/2010/main" val="0"/>
               </a:ext>
               <a:ext uri="{96DAC541-7B7A-43D3-8B79-37D633B846F1}">
-                <asvg:svgBlip xmlns:asvg="http://schemas.microsoft.com/office/drawing/2016/SVG/main" xmlns="" r:embed="rId5"/>
+                <asvg:svgBlip xmlns="" xmlns:asvg="http://schemas.microsoft.com/office/drawing/2016/SVG/main" r:embed="rId5"/>
               </a:ext>
             </a:extLst>
           </a:blip>
@@ -12056,7 +11973,7 @@
                 <a14:useLocalDpi xmlns:a14="http://schemas.microsoft.com/office/drawing/2010/main" val="0"/>
               </a:ext>
               <a:ext uri="{96DAC541-7B7A-43D3-8B79-37D633B846F1}">
-                <asvg:svgBlip xmlns:asvg="http://schemas.microsoft.com/office/drawing/2016/SVG/main" xmlns="" r:embed="rId7"/>
+                <asvg:svgBlip xmlns="" xmlns:asvg="http://schemas.microsoft.com/office/drawing/2016/SVG/main" r:embed="rId7"/>
               </a:ext>
             </a:extLst>
           </a:blip>
@@ -12095,7 +12012,7 @@
                 <a14:useLocalDpi xmlns:a14="http://schemas.microsoft.com/office/drawing/2010/main" val="0"/>
               </a:ext>
               <a:ext uri="{96DAC541-7B7A-43D3-8B79-37D633B846F1}">
-                <asvg:svgBlip xmlns:asvg="http://schemas.microsoft.com/office/drawing/2016/SVG/main" xmlns="" r:embed="rId9"/>
+                <asvg:svgBlip xmlns="" xmlns:asvg="http://schemas.microsoft.com/office/drawing/2016/SVG/main" r:embed="rId9"/>
               </a:ext>
             </a:extLst>
           </a:blip>
@@ -12134,7 +12051,7 @@
                 <a14:useLocalDpi xmlns:a14="http://schemas.microsoft.com/office/drawing/2010/main" val="0"/>
               </a:ext>
               <a:ext uri="{96DAC541-7B7A-43D3-8B79-37D633B846F1}">
-                <asvg:svgBlip xmlns:asvg="http://schemas.microsoft.com/office/drawing/2016/SVG/main" xmlns="" r:embed="rId11"/>
+                <asvg:svgBlip xmlns="" xmlns:asvg="http://schemas.microsoft.com/office/drawing/2016/SVG/main" r:embed="rId11"/>
               </a:ext>
             </a:extLst>
           </a:blip>
@@ -12173,7 +12090,7 @@
                 <a14:useLocalDpi xmlns:a14="http://schemas.microsoft.com/office/drawing/2010/main" val="0"/>
               </a:ext>
               <a:ext uri="{96DAC541-7B7A-43D3-8B79-37D633B846F1}">
-                <asvg:svgBlip xmlns:asvg="http://schemas.microsoft.com/office/drawing/2016/SVG/main" xmlns="" r:embed="rId13"/>
+                <asvg:svgBlip xmlns="" xmlns:asvg="http://schemas.microsoft.com/office/drawing/2016/SVG/main" r:embed="rId13"/>
               </a:ext>
             </a:extLst>
           </a:blip>

</xml_diff>

<commit_message>
updates after the first run in 2023
</commit_message>
<xml_diff>
--- a/instructors/01-Why_are_we_here.pptx
+++ b/instructors/01-Why_are_we_here.pptx
@@ -143,6 +143,51 @@
 </p:presentation>
 </file>
 
+<file path=ppt/revisionInfo.xml><?xml version="1.0" encoding="utf-8"?>
+<p1510:revInfo xmlns:a="http://schemas.openxmlformats.org/drawingml/2006/main" xmlns:r="http://schemas.openxmlformats.org/officeDocument/2006/relationships" xmlns:p1510="http://schemas.microsoft.com/office/powerpoint/2015/10/main">
+  <p1510:revLst>
+    <p1510:client id="{C607FB02-5D6C-41DC-8F29-2D84E2F8A964}" v="1" dt="2022-12-20T09:48:14.126"/>
+  </p1510:revLst>
+</p1510:revInfo>
+</file>
+
+<file path=ppt/changesInfos/changesInfo1.xml><?xml version="1.0" encoding="utf-8"?>
+<pc:chgInfo xmlns:a="http://schemas.openxmlformats.org/drawingml/2006/main" xmlns:r="http://schemas.openxmlformats.org/officeDocument/2006/relationships" xmlns:ac="http://schemas.microsoft.com/office/drawing/2013/main/command" xmlns:pc="http://schemas.microsoft.com/office/powerpoint/2013/main/command">
+  <pc:docChgLst>
+    <pc:chgData name="Tomasz Zielinski" userId="d5c7bb8c-2ef3-45c1-b942-424604992d56" providerId="ADAL" clId="{C607FB02-5D6C-41DC-8F29-2D84E2F8A964}"/>
+    <pc:docChg chg="custSel modSld">
+      <pc:chgData name="Tomasz Zielinski" userId="d5c7bb8c-2ef3-45c1-b942-424604992d56" providerId="ADAL" clId="{C607FB02-5D6C-41DC-8F29-2D84E2F8A964}" dt="2022-12-20T09:48:14.126" v="1"/>
+      <pc:docMkLst>
+        <pc:docMk/>
+      </pc:docMkLst>
+      <pc:sldChg chg="addSp delSp modSp mod">
+        <pc:chgData name="Tomasz Zielinski" userId="d5c7bb8c-2ef3-45c1-b942-424604992d56" providerId="ADAL" clId="{C607FB02-5D6C-41DC-8F29-2D84E2F8A964}" dt="2022-12-20T09:48:14.126" v="1"/>
+        <pc:sldMkLst>
+          <pc:docMk/>
+          <pc:sldMk cId="2056280142" sldId="282"/>
+        </pc:sldMkLst>
+        <pc:picChg chg="add mod">
+          <ac:chgData name="Tomasz Zielinski" userId="d5c7bb8c-2ef3-45c1-b942-424604992d56" providerId="ADAL" clId="{C607FB02-5D6C-41DC-8F29-2D84E2F8A964}" dt="2022-12-20T09:48:14.126" v="1"/>
+          <ac:picMkLst>
+            <pc:docMk/>
+            <pc:sldMk cId="2056280142" sldId="282"/>
+            <ac:picMk id="4" creationId="{00987619-96D4-A25B-3130-BCC3F31E679D}"/>
+          </ac:picMkLst>
+        </pc:picChg>
+        <pc:picChg chg="del">
+          <ac:chgData name="Tomasz Zielinski" userId="d5c7bb8c-2ef3-45c1-b942-424604992d56" providerId="ADAL" clId="{C607FB02-5D6C-41DC-8F29-2D84E2F8A964}" dt="2022-12-20T09:48:13.209" v="0" actId="478"/>
+          <ac:picMkLst>
+            <pc:docMk/>
+            <pc:sldMk cId="2056280142" sldId="282"/>
+            <ac:picMk id="7" creationId="{EF48B542-D926-429F-B4A1-391E8A5A4940}"/>
+          </ac:picMkLst>
+        </pc:picChg>
+      </pc:sldChg>
+    </pc:docChg>
+  </pc:docChgLst>
+</pc:chgInfo>
+</file>
+
 <file path=ppt/notesMasters/notesMaster1.xml><?xml version="1.0" encoding="utf-8"?>
 <p:notesMaster xmlns:a="http://schemas.openxmlformats.org/drawingml/2006/main" xmlns:r="http://schemas.openxmlformats.org/officeDocument/2006/relationships" xmlns:p="http://schemas.openxmlformats.org/presentationml/2006/main">
   <p:cSld>
@@ -225,7 +270,7 @@
           <a:p>
             <a:fld id="{B1D4AFAA-5545-4348-866E-082827204B28}" type="datetimeFigureOut">
               <a:rPr lang="en-GB" smtClean="0"/>
-              <a:t>16/12/2022</a:t>
+              <a:t>10/01/2024</a:t>
             </a:fld>
             <a:endParaRPr lang="en-GB"/>
           </a:p>
@@ -289,35 +334,35 @@
           <a:p>
             <a:pPr lvl="0"/>
             <a:r>
-              <a:rPr lang="en-US" smtClean="0"/>
+              <a:rPr lang="en-US"/>
               <a:t>Edit Master text styles</a:t>
             </a:r>
           </a:p>
           <a:p>
             <a:pPr lvl="1"/>
             <a:r>
-              <a:rPr lang="en-US" smtClean="0"/>
+              <a:rPr lang="en-US"/>
               <a:t>Second level</a:t>
             </a:r>
           </a:p>
           <a:p>
             <a:pPr lvl="2"/>
             <a:r>
-              <a:rPr lang="en-US" smtClean="0"/>
+              <a:rPr lang="en-US"/>
               <a:t>Third level</a:t>
             </a:r>
           </a:p>
           <a:p>
             <a:pPr lvl="3"/>
             <a:r>
-              <a:rPr lang="en-US" smtClean="0"/>
+              <a:rPr lang="en-US"/>
               <a:t>Fourth level</a:t>
             </a:r>
           </a:p>
           <a:p>
             <a:pPr lvl="4"/>
             <a:r>
-              <a:rPr lang="en-US" smtClean="0"/>
+              <a:rPr lang="en-US"/>
               <a:t>Fifth level</a:t>
             </a:r>
             <a:endParaRPr lang="en-GB"/>
@@ -538,21 +583,21 @@
           <a:lstStyle/>
           <a:p>
             <a:r>
-              <a:rPr lang="en-US" dirty="0" err="1" smtClean="0"/>
+              <a:rPr lang="en-US" dirty="0" err="1"/>
               <a:t>Wellcome</a:t>
             </a:r>
             <a:r>
-              <a:rPr lang="en-US" dirty="0" smtClean="0"/>
+              <a:rPr lang="en-US" dirty="0"/>
               <a:t> example: https://wellcome.ac.uk/news/how-we-judge-research-outputs-when-making-funding-decisions</a:t>
             </a:r>
           </a:p>
           <a:p>
             <a:r>
-              <a:rPr lang="en-US" dirty="0" smtClean="0"/>
+              <a:rPr lang="en-US" dirty="0"/>
               <a:t>Cancer Research</a:t>
             </a:r>
             <a:r>
-              <a:rPr lang="en-US" baseline="0" dirty="0" smtClean="0"/>
+              <a:rPr lang="en-US" baseline="0" dirty="0"/>
               <a:t> UK example: https://www.cancerresearchuk.org/funding-for-researchers/research-features/2018-02-20-improving-research-evaluation-dora</a:t>
             </a:r>
           </a:p>
@@ -619,11 +664,11 @@
           <a:lstStyle/>
           <a:p>
             <a:r>
-              <a:rPr lang="en-GB" smtClean="0"/>
+              <a:rPr lang="en-GB"/>
               <a:t>Colin and Chris Weir are a Scottish couple who won</a:t>
             </a:r>
             <a:r>
-              <a:rPr lang="en-GB" baseline="0" smtClean="0"/>
+              <a:rPr lang="en-GB" baseline="0"/>
               <a:t> a life-changing sum of money in the national lottery. Would your postdoc come back into work if they hit the jackpot? </a:t>
             </a:r>
             <a:endParaRPr lang="en-GB"/>
@@ -797,7 +842,7 @@
           <a:p>
             <a:fld id="{CC29EC85-173F-467E-B364-65AD14726A23}" type="datetimeFigureOut">
               <a:rPr lang="en-GB" smtClean="0"/>
-              <a:t>16/12/2022</a:t>
+              <a:t>10/01/2024</a:t>
             </a:fld>
             <a:endParaRPr lang="en-GB"/>
           </a:p>
@@ -1014,7 +1059,7 @@
           <a:p>
             <a:fld id="{CC29EC85-173F-467E-B364-65AD14726A23}" type="datetimeFigureOut">
               <a:rPr lang="en-GB" smtClean="0"/>
-              <a:t>16/12/2022</a:t>
+              <a:t>10/01/2024</a:t>
             </a:fld>
             <a:endParaRPr lang="en-GB"/>
           </a:p>
@@ -1194,7 +1239,7 @@
           <a:p>
             <a:fld id="{CC29EC85-173F-467E-B364-65AD14726A23}" type="datetimeFigureOut">
               <a:rPr lang="en-GB" smtClean="0"/>
-              <a:t>16/12/2022</a:t>
+              <a:t>10/01/2024</a:t>
             </a:fld>
             <a:endParaRPr lang="en-GB"/>
           </a:p>
@@ -1557,7 +1602,7 @@
           <a:p>
             <a:fld id="{CC29EC85-173F-467E-B364-65AD14726A23}" type="datetimeFigureOut">
               <a:rPr lang="en-GB" smtClean="0"/>
-              <a:t>16/12/2022</a:t>
+              <a:t>10/01/2024</a:t>
             </a:fld>
             <a:endParaRPr lang="en-GB"/>
           </a:p>
@@ -1803,7 +1848,7 @@
           <a:p>
             <a:fld id="{CC29EC85-173F-467E-B364-65AD14726A23}" type="datetimeFigureOut">
               <a:rPr lang="en-GB" smtClean="0"/>
-              <a:t>16/12/2022</a:t>
+              <a:t>10/01/2024</a:t>
             </a:fld>
             <a:endParaRPr lang="en-GB"/>
           </a:p>
@@ -2035,7 +2080,7 @@
           <a:p>
             <a:fld id="{CC29EC85-173F-467E-B364-65AD14726A23}" type="datetimeFigureOut">
               <a:rPr lang="en-GB" smtClean="0"/>
-              <a:t>16/12/2022</a:t>
+              <a:t>10/01/2024</a:t>
             </a:fld>
             <a:endParaRPr lang="en-GB"/>
           </a:p>
@@ -2402,7 +2447,7 @@
           <a:p>
             <a:fld id="{CC29EC85-173F-467E-B364-65AD14726A23}" type="datetimeFigureOut">
               <a:rPr lang="en-GB" smtClean="0"/>
-              <a:t>16/12/2022</a:t>
+              <a:t>10/01/2024</a:t>
             </a:fld>
             <a:endParaRPr lang="en-GB"/>
           </a:p>
@@ -2520,7 +2565,7 @@
           <a:p>
             <a:fld id="{CC29EC85-173F-467E-B364-65AD14726A23}" type="datetimeFigureOut">
               <a:rPr lang="en-GB" smtClean="0"/>
-              <a:t>16/12/2022</a:t>
+              <a:t>10/01/2024</a:t>
             </a:fld>
             <a:endParaRPr lang="en-GB"/>
           </a:p>
@@ -2615,7 +2660,7 @@
           <a:p>
             <a:fld id="{CC29EC85-173F-467E-B364-65AD14726A23}" type="datetimeFigureOut">
               <a:rPr lang="en-GB" smtClean="0"/>
-              <a:t>16/12/2022</a:t>
+              <a:t>10/01/2024</a:t>
             </a:fld>
             <a:endParaRPr lang="en-GB"/>
           </a:p>
@@ -2892,7 +2937,7 @@
           <a:p>
             <a:fld id="{CC29EC85-173F-467E-B364-65AD14726A23}" type="datetimeFigureOut">
               <a:rPr lang="en-GB" smtClean="0"/>
-              <a:t>16/12/2022</a:t>
+              <a:t>10/01/2024</a:t>
             </a:fld>
             <a:endParaRPr lang="en-GB"/>
           </a:p>
@@ -3145,7 +3190,7 @@
           <a:p>
             <a:fld id="{CC29EC85-173F-467E-B364-65AD14726A23}" type="datetimeFigureOut">
               <a:rPr lang="en-GB" smtClean="0"/>
-              <a:t>16/12/2022</a:t>
+              <a:t>10/01/2024</a:t>
             </a:fld>
             <a:endParaRPr lang="en-GB"/>
           </a:p>
@@ -3357,7 +3402,7 @@
             <a:fld id="{CC29EC85-173F-467E-B364-65AD14726A23}" type="datetimeFigureOut">
               <a:rPr lang="en-GB" smtClean="0"/>
               <a:pPr/>
-              <a:t>16/12/2022</a:t>
+              <a:t>10/01/2024</a:t>
             </a:fld>
             <a:endParaRPr lang="en-GB"/>
           </a:p>
@@ -3823,7 +3868,7 @@
           <a:lstStyle/>
           <a:p>
             <a:r>
-              <a:rPr lang="pl-PL" smtClean="0"/>
+              <a:rPr lang="pl-PL"/>
               <a:t>FAIR for leaders</a:t>
             </a:r>
             <a:endParaRPr lang="en-GB" dirty="0"/>
@@ -3895,13 +3940,6 @@
   <p:clrMapOvr>
     <a:masterClrMapping/>
   </p:clrMapOvr>
-  <p:timing>
-    <p:tnLst>
-      <p:par>
-        <p:cTn id="1" dur="indefinite" restart="never" nodeType="tmRoot"/>
-      </p:par>
-    </p:tnLst>
-  </p:timing>
 </p:sld>
 </file>
 
@@ -4003,12 +4041,8 @@
           </a:p>
           <a:p>
             <a:r>
-              <a:rPr lang="pl-PL" sz="2400" dirty="0" smtClean="0"/>
-              <a:t>Unpublished/negative </a:t>
-            </a:r>
-            <a:r>
               <a:rPr lang="pl-PL" sz="2400" dirty="0"/>
-              <a:t>results</a:t>
+              <a:t>Unpublished/negative results</a:t>
             </a:r>
           </a:p>
           <a:p>
@@ -4065,10 +4099,10 @@
       </p:sp>
       <p:pic>
         <p:nvPicPr>
-          <p:cNvPr id="7" name="Graphic 6" descr="Questionnaire">
+          <p:cNvPr id="4" name="Graphic 6" descr="Questionnaire">
             <a:extLst>
               <a:ext uri="{FF2B5EF4-FFF2-40B4-BE49-F238E27FC236}">
-                <a16:creationId xmlns:a16="http://schemas.microsoft.com/office/drawing/2014/main" id="{EF48B542-D926-429F-B4A1-391E8A5A4940}"/>
+                <a16:creationId xmlns:a16="http://schemas.microsoft.com/office/drawing/2014/main" id="{00987619-96D4-A25B-3130-BCC3F31E679D}"/>
               </a:ext>
             </a:extLst>
           </p:cNvPr>
@@ -4084,7 +4118,7 @@
                 <a14:useLocalDpi xmlns:a14="http://schemas.microsoft.com/office/drawing/2010/main" val="0"/>
               </a:ext>
               <a:ext uri="{96DAC541-7B7A-43D3-8B79-37D633B846F1}">
-                <asvg:svgBlip xmlns="" xmlns:asvg="http://schemas.microsoft.com/office/drawing/2016/SVG/main" r:embed="rId3"/>
+                <asvg:svgBlip xmlns:asvg="http://schemas.microsoft.com/office/drawing/2016/SVG/main" r:embed="rId3"/>
               </a:ext>
             </a:extLst>
           </a:blip>
@@ -4215,6 +4249,12 @@
             <a:r>
               <a:rPr lang="en-GB" sz="2400" dirty="0"/>
               <a:t> Trust are big supporters of Open Science</a:t>
+            </a:r>
+          </a:p>
+          <a:p>
+            <a:r>
+              <a:rPr lang="en-GB" sz="2400" dirty="0"/>
+              <a:t>UK REF2021 required OA publications</a:t>
             </a:r>
           </a:p>
           <a:p>
@@ -5325,7 +5365,7 @@
               <a:buNone/>
             </a:pPr>
             <a:r>
-              <a:rPr lang="en-GB" sz="2400" dirty="0" smtClean="0"/>
+              <a:rPr lang="en-GB" sz="2400" dirty="0"/>
               <a:t>“carrots”</a:t>
             </a:r>
           </a:p>
@@ -5337,27 +5377,15 @@
           </a:p>
           <a:p>
             <a:r>
-              <a:rPr lang="en-GB" sz="2400" dirty="0" smtClean="0"/>
-              <a:t>get </a:t>
-            </a:r>
-            <a:r>
               <a:rPr lang="en-GB" sz="2400" dirty="0"/>
-              <a:t>extra value from your </a:t>
-            </a:r>
-            <a:r>
-              <a:rPr lang="en-GB" sz="2400" dirty="0" smtClean="0"/>
-              <a:t>work</a:t>
+              <a:t>get extra value from your work</a:t>
             </a:r>
             <a:br>
-              <a:rPr lang="en-GB" sz="2400" dirty="0" smtClean="0"/>
+              <a:rPr lang="en-GB" sz="2400" dirty="0"/>
             </a:br>
             <a:r>
-              <a:rPr lang="en-GB" sz="2400" dirty="0" smtClean="0"/>
-              <a:t>(e.g</a:t>
-            </a:r>
-            <a:r>
               <a:rPr lang="en-GB" sz="2400" dirty="0"/>
-              <a:t>. collaborators, reuse)</a:t>
+              <a:t>(e.g. collaborators, reuse)</a:t>
             </a:r>
           </a:p>
           <a:p>
@@ -5365,12 +5393,8 @@
               <a:buNone/>
             </a:pPr>
             <a:r>
-              <a:rPr lang="en-GB" sz="2400" dirty="0" smtClean="0"/>
-              <a:t>• save </a:t>
-            </a:r>
-            <a:r>
               <a:rPr lang="en-GB" sz="2400" dirty="0"/>
-              <a:t>own time (reproducibility but also communication overhead)  </a:t>
+              <a:t>• save own time (reproducibility but also communication overhead)  </a:t>
             </a:r>
           </a:p>
           <a:p>
@@ -5378,12 +5402,8 @@
               <a:buNone/>
             </a:pPr>
             <a:r>
-              <a:rPr lang="en-GB" sz="2400" dirty="0" smtClean="0"/>
-              <a:t>• build </a:t>
-            </a:r>
-            <a:r>
               <a:rPr lang="en-GB" sz="2400" dirty="0"/>
-              <a:t>reputation and presence in the science community </a:t>
+              <a:t>• build reputation and presence in the science community </a:t>
             </a:r>
           </a:p>
           <a:p>
@@ -5391,14 +5411,9 @@
               <a:buNone/>
             </a:pPr>
             <a:r>
-              <a:rPr lang="en-GB" sz="2400" dirty="0" smtClean="0"/>
-              <a:t>• evidence </a:t>
-            </a:r>
-            <a:r>
               <a:rPr lang="en-GB" sz="2400" dirty="0"/>
-              <a:t>of your scientific rigour and work ethic.</a:t>
-            </a:r>
-            <a:endParaRPr lang="en-GB" sz="2400" dirty="0"/>
+              <a:t>• evidence of your scientific rigour and work ethic.</a:t>
+            </a:r>
           </a:p>
           <a:p>
             <a:endParaRPr lang="en-GB" sz="2400" dirty="0"/>
@@ -5415,13 +5430,6 @@
   <p:clrMapOvr>
     <a:masterClrMapping/>
   </p:clrMapOvr>
-  <p:timing>
-    <p:tnLst>
-      <p:par>
-        <p:cTn id="1" dur="indefinite" restart="never" nodeType="tmRoot"/>
-      </p:par>
-    </p:tnLst>
-  </p:timing>
 </p:sld>
 </file>
 
@@ -5467,14 +5475,10 @@
           <a:p>
             <a:r>
               <a:rPr lang="en-GB" sz="3600" dirty="0"/>
-              <a:t>Why we are not doing Open </a:t>
-            </a:r>
-            <a:r>
-              <a:rPr lang="en-GB" sz="3600" dirty="0" smtClean="0"/>
-              <a:t>Science</a:t>
-            </a:r>
-            <a:r>
-              <a:rPr lang="pl-PL" sz="3600" dirty="0" smtClean="0"/>
+              <a:t>Why we are not doing Open Science</a:t>
+            </a:r>
+            <a:r>
+              <a:rPr lang="pl-PL" sz="3600" dirty="0"/>
               <a:t> / Data Sharing</a:t>
             </a:r>
             <a:endParaRPr lang="en-GB" sz="3600" dirty="0"/>
@@ -5533,7 +5537,7 @@
                 <a14:useLocalDpi xmlns:a14="http://schemas.microsoft.com/office/drawing/2010/main" val="0"/>
               </a:ext>
               <a:ext uri="{96DAC541-7B7A-43D3-8B79-37D633B846F1}">
-                <asvg:svgBlip xmlns:asvg="http://schemas.microsoft.com/office/drawing/2016/SVG/main" xmlns="" r:embed="rId3"/>
+                <asvg:svgBlip xmlns:asvg="http://schemas.microsoft.com/office/drawing/2016/SVG/main" r:embed="rId3"/>
               </a:ext>
             </a:extLst>
           </a:blip>
@@ -5561,13 +5565,6 @@
   <p:clrMapOvr>
     <a:masterClrMapping/>
   </p:clrMapOvr>
-  <p:timing>
-    <p:tnLst>
-      <p:par>
-        <p:cTn id="1" dur="indefinite" restart="never" nodeType="tmRoot"/>
-      </p:par>
-    </p:tnLst>
-  </p:timing>
 </p:sld>
 </file>
 
@@ -5616,7 +5613,7 @@
               <a:t>Why we are not doing Open Science </a:t>
             </a:r>
             <a:r>
-              <a:rPr lang="pl-PL" sz="3600" dirty="0" smtClean="0"/>
+              <a:rPr lang="pl-PL" sz="3600" dirty="0"/>
               <a:t>/ Data Sharing</a:t>
             </a:r>
             <a:endParaRPr lang="en-GB" sz="3600" dirty="0"/>
@@ -5705,7 +5702,7 @@
             </a:pPr>
             <a:r>
               <a:rPr lang="en-GB" b="1" dirty="0"/>
-              <a:t>the costs in $ and in time</a:t>
+              <a:t>the costs in ££ and in time</a:t>
             </a:r>
           </a:p>
           <a:p>
@@ -5748,7 +5745,7 @@
                 <a14:useLocalDpi xmlns:a14="http://schemas.microsoft.com/office/drawing/2010/main" val="0"/>
               </a:ext>
               <a:ext uri="{96DAC541-7B7A-43D3-8B79-37D633B846F1}">
-                <asvg:svgBlip xmlns:asvg="http://schemas.microsoft.com/office/drawing/2016/SVG/main" xmlns="" r:embed="rId3"/>
+                <asvg:svgBlip xmlns:asvg="http://schemas.microsoft.com/office/drawing/2016/SVG/main" r:embed="rId3"/>
               </a:ext>
             </a:extLst>
           </a:blip>
@@ -5776,13 +5773,6 @@
   <p:clrMapOvr>
     <a:masterClrMapping/>
   </p:clrMapOvr>
-  <p:timing>
-    <p:tnLst>
-      <p:par>
-        <p:cTn id="1" dur="indefinite" restart="never" nodeType="tmRoot"/>
-      </p:par>
-    </p:tnLst>
-  </p:timing>
 </p:sld>
 </file>
 
@@ -7059,7 +7049,7 @@
             <a:effectLst/>
             <a:extLst>
               <a:ext uri="{AF507438-7753-43e0-B8FC-AC1667EBCBE1}">
-                <a14:hiddenEffects xmlns:a14="http://schemas.microsoft.com/office/drawing/2010/main" xmlns="">
+                <a14:hiddenEffects xmlns="" xmlns:a14="http://schemas.microsoft.com/office/drawing/2010/main">
                   <a:effectLst>
                     <a:outerShdw dist="35921" dir="2700000" algn="ctr" rotWithShape="0">
                       <a:schemeClr val="bg2"/>
@@ -7121,7 +7111,7 @@
             <a:effectLst/>
             <a:extLst>
               <a:ext uri="{AF507438-7753-43e0-B8FC-AC1667EBCBE1}">
-                <a14:hiddenEffects xmlns:a14="http://schemas.microsoft.com/office/drawing/2010/main" xmlns="">
+                <a14:hiddenEffects xmlns="" xmlns:a14="http://schemas.microsoft.com/office/drawing/2010/main">
                   <a:effectLst>
                     <a:outerShdw dist="35921" dir="2700000" algn="ctr" rotWithShape="0">
                       <a:schemeClr val="bg2"/>
@@ -7183,7 +7173,7 @@
             <a:effectLst/>
             <a:extLst>
               <a:ext uri="{AF507438-7753-43e0-B8FC-AC1667EBCBE1}">
-                <a14:hiddenEffects xmlns:a14="http://schemas.microsoft.com/office/drawing/2010/main" xmlns="">
+                <a14:hiddenEffects xmlns="" xmlns:a14="http://schemas.microsoft.com/office/drawing/2010/main">
                   <a:effectLst>
                     <a:outerShdw dist="35921" dir="2700000" algn="ctr" rotWithShape="0">
                       <a:schemeClr val="bg2"/>
@@ -7290,13 +7280,6 @@
   <p:clrMapOvr>
     <a:masterClrMapping/>
   </p:clrMapOvr>
-  <p:timing>
-    <p:tnLst>
-      <p:par>
-        <p:cTn id="1" dur="indefinite" restart="never" nodeType="tmRoot"/>
-      </p:par>
-    </p:tnLst>
-  </p:timing>
 </p:sld>
 </file>
 
@@ -7389,7 +7372,7 @@
           <a:effectLst/>
           <a:extLst>
             <a:ext uri="{AF507438-7753-43e0-B8FC-AC1667EBCBE1}">
-              <a14:hiddenEffects xmlns:a14="http://schemas.microsoft.com/office/drawing/2010/main" xmlns="">
+              <a14:hiddenEffects xmlns="" xmlns:a14="http://schemas.microsoft.com/office/drawing/2010/main">
                 <a:effectLst>
                   <a:outerShdw dist="35921" dir="2700000" algn="ctr" rotWithShape="0">
                     <a:schemeClr val="bg2"/>
@@ -7720,7 +7703,7 @@
             <a:effectLst/>
             <a:extLst>
               <a:ext uri="{AF507438-7753-43e0-B8FC-AC1667EBCBE1}">
-                <a14:hiddenEffects xmlns:a14="http://schemas.microsoft.com/office/drawing/2010/main" xmlns="">
+                <a14:hiddenEffects xmlns="" xmlns:a14="http://schemas.microsoft.com/office/drawing/2010/main">
                   <a:effectLst>
                     <a:outerShdw dist="35921" dir="2700000" algn="ctr" rotWithShape="0">
                       <a:schemeClr val="bg2"/>
@@ -7782,7 +7765,7 @@
             <a:effectLst/>
             <a:extLst>
               <a:ext uri="{AF507438-7753-43e0-B8FC-AC1667EBCBE1}">
-                <a14:hiddenEffects xmlns:a14="http://schemas.microsoft.com/office/drawing/2010/main" xmlns="">
+                <a14:hiddenEffects xmlns="" xmlns:a14="http://schemas.microsoft.com/office/drawing/2010/main">
                   <a:effectLst>
                     <a:outerShdw dist="35921" dir="2700000" algn="ctr" rotWithShape="0">
                       <a:schemeClr val="bg2"/>
@@ -7859,7 +7842,7 @@
             <a:effectLst/>
             <a:extLst>
               <a:ext uri="{AF507438-7753-43e0-B8FC-AC1667EBCBE1}">
-                <a14:hiddenEffects xmlns:a14="http://schemas.microsoft.com/office/drawing/2010/main" xmlns="">
+                <a14:hiddenEffects xmlns="" xmlns:a14="http://schemas.microsoft.com/office/drawing/2010/main">
                   <a:effectLst>
                     <a:outerShdw dist="35921" dir="2700000" algn="ctr" rotWithShape="0">
                       <a:schemeClr val="bg2"/>
@@ -7921,7 +7904,7 @@
             <a:effectLst/>
             <a:extLst>
               <a:ext uri="{AF507438-7753-43e0-B8FC-AC1667EBCBE1}">
-                <a14:hiddenEffects xmlns:a14="http://schemas.microsoft.com/office/drawing/2010/main" xmlns="">
+                <a14:hiddenEffects xmlns="" xmlns:a14="http://schemas.microsoft.com/office/drawing/2010/main">
                   <a:effectLst>
                     <a:outerShdw dist="35921" dir="2700000" algn="ctr" rotWithShape="0">
                       <a:schemeClr val="bg2"/>
@@ -9154,7 +9137,7 @@
           <a:effectLst/>
           <a:extLst>
             <a:ext uri="{AF507438-7753-43e0-B8FC-AC1667EBCBE1}">
-              <a14:hiddenEffects xmlns:a14="http://schemas.microsoft.com/office/drawing/2010/main" xmlns="">
+              <a14:hiddenEffects xmlns="" xmlns:a14="http://schemas.microsoft.com/office/drawing/2010/main">
                 <a:effectLst>
                   <a:outerShdw dist="35921" dir="2700000" algn="ctr" rotWithShape="0">
                     <a:schemeClr val="bg2"/>
@@ -9404,13 +9387,6 @@
   <p:clrMapOvr>
     <a:masterClrMapping/>
   </p:clrMapOvr>
-  <p:timing>
-    <p:tnLst>
-      <p:par>
-        <p:cTn id="1" dur="indefinite" restart="never" nodeType="tmRoot"/>
-      </p:par>
-    </p:tnLst>
-  </p:timing>
 </p:sld>
 </file>
 
@@ -9481,10 +9457,9 @@
               <a:buNone/>
             </a:pPr>
             <a:r>
-              <a:rPr lang="en-GB" sz="4000" dirty="0" smtClean="0"/>
+              <a:rPr lang="en-GB" sz="4000" dirty="0"/>
               <a:t>Why you should know it</a:t>
             </a:r>
-            <a:endParaRPr lang="en-GB" sz="4000" dirty="0"/>
           </a:p>
         </p:txBody>
       </p:sp>
@@ -9498,13 +9473,6 @@
   <p:clrMapOvr>
     <a:masterClrMapping/>
   </p:clrMapOvr>
-  <p:timing>
-    <p:tnLst>
-      <p:par>
-        <p:cTn id="1" dur="indefinite" restart="never" nodeType="tmRoot"/>
-      </p:par>
-    </p:tnLst>
-  </p:timing>
 </p:sld>
 </file>
 
@@ -9587,10 +9555,9 @@
           <a:lstStyle/>
           <a:p>
             <a:r>
-              <a:rPr lang="en-GB" dirty="0" smtClean="0"/>
+              <a:rPr lang="en-GB" dirty="0"/>
               <a:t>Power figures</a:t>
             </a:r>
-            <a:endParaRPr lang="en-GB" dirty="0"/>
           </a:p>
         </p:txBody>
       </p:sp>
@@ -9812,23 +9779,15 @@
           <a:p>
             <a:r>
               <a:rPr lang="en-GB" sz="1400" dirty="0"/>
-              <a:t>CREDITS </a:t>
-            </a:r>
-            <a:r>
-              <a:rPr lang="en-GB" sz="1400" dirty="0" smtClean="0"/>
-              <a:t>[</a:t>
-            </a:r>
-            <a:r>
-              <a:rPr lang="pl-PL" sz="1400" dirty="0" smtClean="0"/>
+              <a:t>CREDITS [</a:t>
+            </a:r>
+            <a:r>
+              <a:rPr lang="pl-PL" sz="1400" dirty="0"/>
               <a:t>2, 3</a:t>
             </a:r>
             <a:r>
-              <a:rPr lang="en-GB" sz="1400" dirty="0" smtClean="0"/>
-              <a:t>] </a:t>
-            </a:r>
-            <a:r>
               <a:rPr lang="en-GB" sz="1400" dirty="0"/>
-              <a:t>CC BY</a:t>
+              <a:t>] CC BY</a:t>
             </a:r>
           </a:p>
         </p:txBody>
@@ -9843,13 +9802,6 @@
   <p:clrMapOvr>
     <a:masterClrMapping/>
   </p:clrMapOvr>
-  <p:timing>
-    <p:tnLst>
-      <p:par>
-        <p:cTn id="1" dur="indefinite" restart="never" nodeType="tmRoot"/>
-      </p:par>
-    </p:tnLst>
-  </p:timing>
 </p:sld>
 </file>
 
@@ -9886,10 +9838,9 @@
           <a:lstStyle/>
           <a:p>
             <a:r>
-              <a:rPr lang="en-GB" dirty="0" smtClean="0"/>
+              <a:rPr lang="en-GB" dirty="0"/>
               <a:t>Responsible for your minions</a:t>
             </a:r>
-            <a:endParaRPr lang="en-GB" dirty="0"/>
           </a:p>
         </p:txBody>
       </p:sp>
@@ -9924,10 +9875,9 @@
               <a:buNone/>
             </a:pPr>
             <a:r>
-              <a:rPr lang="en-GB" sz="4000" dirty="0" smtClean="0"/>
+              <a:rPr lang="en-GB" sz="4000" dirty="0"/>
               <a:t>Why you should know it</a:t>
             </a:r>
-            <a:endParaRPr lang="en-GB" sz="4000" dirty="0"/>
           </a:p>
         </p:txBody>
       </p:sp>
@@ -9991,23 +9941,15 @@
           <a:p>
             <a:r>
               <a:rPr lang="en-GB" sz="1400" dirty="0"/>
-              <a:t>CREDITS </a:t>
-            </a:r>
-            <a:r>
-              <a:rPr lang="en-GB" sz="1400" dirty="0" smtClean="0"/>
-              <a:t>[</a:t>
-            </a:r>
-            <a:r>
-              <a:rPr lang="pl-PL" sz="1400" dirty="0" smtClean="0"/>
+              <a:t>CREDITS [</a:t>
+            </a:r>
+            <a:r>
+              <a:rPr lang="pl-PL" sz="1400" dirty="0"/>
               <a:t>4</a:t>
             </a:r>
             <a:r>
-              <a:rPr lang="en-GB" sz="1400" dirty="0" smtClean="0"/>
-              <a:t>] </a:t>
-            </a:r>
-            <a:r>
               <a:rPr lang="en-GB" sz="1400" dirty="0"/>
-              <a:t>CC BY</a:t>
+              <a:t>] CC BY</a:t>
             </a:r>
           </a:p>
         </p:txBody>
@@ -10022,13 +9964,6 @@
   <p:clrMapOvr>
     <a:masterClrMapping/>
   </p:clrMapOvr>
-  <p:timing>
-    <p:tnLst>
-      <p:par>
-        <p:cTn id="1" dur="indefinite" restart="never" nodeType="tmRoot"/>
-      </p:par>
-    </p:tnLst>
-  </p:timing>
 </p:sld>
 </file>
 
@@ -10116,13 +10051,6 @@
   <p:clrMapOvr>
     <a:masterClrMapping/>
   </p:clrMapOvr>
-  <p:timing>
-    <p:tnLst>
-      <p:par>
-        <p:cTn id="1" dur="indefinite" restart="never" nodeType="tmRoot"/>
-      </p:par>
-    </p:tnLst>
-  </p:timing>
 </p:sld>
 </file>
 
@@ -10205,10 +10133,9 @@
           <a:lstStyle/>
           <a:p>
             <a:r>
-              <a:rPr lang="en-GB" dirty="0" smtClean="0"/>
+              <a:rPr lang="en-GB" dirty="0"/>
               <a:t>DORA</a:t>
             </a:r>
-            <a:endParaRPr lang="en-GB" dirty="0"/>
           </a:p>
         </p:txBody>
       </p:sp>
@@ -10232,23 +10159,15 @@
             <a:pPr marL="0" indent="0">
               <a:buNone/>
             </a:pPr>
-            <a:endParaRPr lang="en-GB" b="1" dirty="0" smtClean="0"/>
+            <a:endParaRPr lang="en-GB" b="1" dirty="0"/>
           </a:p>
           <a:p>
             <a:pPr marL="0" indent="0">
               <a:buNone/>
             </a:pPr>
             <a:r>
-              <a:rPr lang="en-GB" b="1" dirty="0" smtClean="0"/>
-              <a:t>Declaration </a:t>
-            </a:r>
-            <a:r>
               <a:rPr lang="en-GB" b="1" dirty="0"/>
-              <a:t>on Research </a:t>
-            </a:r>
-            <a:r>
-              <a:rPr lang="en-GB" b="1" dirty="0" smtClean="0"/>
-              <a:t>Assessment</a:t>
+              <a:t>Declaration on Research Assessment</a:t>
             </a:r>
           </a:p>
           <a:p>
@@ -10262,42 +10181,20 @@
               <a:rPr lang="en-GB" dirty="0"/>
               <a:t>the need to assess research on its own merits rather than on the basis of the journal </a:t>
             </a:r>
-            <a:endParaRPr lang="en-GB" dirty="0" smtClean="0"/>
-          </a:p>
-          <a:p>
-            <a:r>
-              <a:rPr lang="en-GB" dirty="0" smtClean="0"/>
-              <a:t>the </a:t>
-            </a:r>
+          </a:p>
+          <a:p>
             <a:r>
               <a:rPr lang="en-GB" dirty="0"/>
-              <a:t>need </a:t>
+              <a:t>the need </a:t>
             </a:r>
             <a:r>
               <a:rPr lang="en-GB"/>
-              <a:t>to </a:t>
-            </a:r>
-            <a:r>
-              <a:rPr lang="en-GB" smtClean="0"/>
-              <a:t>capitalise </a:t>
+              <a:t>to capitalise </a:t>
             </a:r>
             <a:r>
               <a:rPr lang="en-GB" dirty="0"/>
-              <a:t>on the opportunities provided by online publication (such as relaxing unnecessary limits </a:t>
-            </a:r>
-            <a:r>
-              <a:rPr lang="en-GB" dirty="0" smtClean="0"/>
-              <a:t>… </a:t>
-            </a:r>
-            <a:r>
-              <a:rPr lang="en-GB" dirty="0"/>
-              <a:t>exploring new indicators of significance and impact</a:t>
-            </a:r>
-            <a:r>
-              <a:rPr lang="en-GB" dirty="0" smtClean="0"/>
-              <a:t>)</a:t>
-            </a:r>
-            <a:endParaRPr lang="en-GB" dirty="0"/>
+              <a:t>on the opportunities provided by online publication (such as relaxing unnecessary limits … exploring new indicators of significance and impact)</a:t>
+            </a:r>
           </a:p>
           <a:p>
             <a:pPr marL="0" indent="0">
@@ -10337,23 +10234,15 @@
           <a:p>
             <a:r>
               <a:rPr lang="en-GB" sz="1400" dirty="0"/>
-              <a:t>CREDITS </a:t>
-            </a:r>
-            <a:r>
-              <a:rPr lang="en-GB" sz="1400" dirty="0" smtClean="0"/>
-              <a:t>[</a:t>
-            </a:r>
-            <a:r>
-              <a:rPr lang="pl-PL" sz="1400" dirty="0" smtClean="0"/>
+              <a:t>CREDITS [</a:t>
+            </a:r>
+            <a:r>
+              <a:rPr lang="pl-PL" sz="1400" dirty="0"/>
               <a:t>5</a:t>
             </a:r>
             <a:r>
-              <a:rPr lang="en-GB" sz="1400" dirty="0" smtClean="0"/>
-              <a:t>] </a:t>
-            </a:r>
-            <a:r>
               <a:rPr lang="en-GB" sz="1400" dirty="0"/>
-              <a:t>CC BY</a:t>
+              <a:t>] CC BY</a:t>
             </a:r>
           </a:p>
         </p:txBody>
@@ -10368,13 +10257,6 @@
   <p:clrMapOvr>
     <a:masterClrMapping/>
   </p:clrMapOvr>
-  <p:timing>
-    <p:tnLst>
-      <p:par>
-        <p:cTn id="1" dur="indefinite" restart="never" nodeType="tmRoot"/>
-      </p:par>
-    </p:tnLst>
-  </p:timing>
 </p:sld>
 </file>
 
@@ -10755,17 +10637,11 @@
               </a:rPr>
               <a:t>committee </a:t>
             </a:r>
-            <a:endParaRPr lang="en-US" sz="1600" smtClean="0">
-              <a:solidFill>
-                <a:srgbClr val="0070C0"/>
-              </a:solidFill>
-              <a:sym typeface="Helvetica Neue"/>
-            </a:endParaRPr>
           </a:p>
           <a:p>
             <a:pPr defTabSz="412750" hangingPunct="0"/>
             <a:r>
-              <a:rPr lang="en-US" sz="1600" smtClean="0">
+              <a:rPr lang="en-US" sz="1600">
                 <a:solidFill>
                   <a:srgbClr val="0070C0"/>
                 </a:solidFill>
@@ -10791,17 +10667,11 @@
               </a:rPr>
               <a:t>throughout </a:t>
             </a:r>
-            <a:endParaRPr lang="en-US" sz="1600" smtClean="0">
-              <a:solidFill>
-                <a:srgbClr val="0070C0"/>
-              </a:solidFill>
-              <a:sym typeface="Helvetica Neue"/>
-            </a:endParaRPr>
           </a:p>
           <a:p>
             <a:pPr defTabSz="412750" hangingPunct="0"/>
             <a:r>
-              <a:rPr lang="en-US" sz="1600" smtClean="0">
+              <a:rPr lang="en-US" sz="1600">
                 <a:solidFill>
                   <a:srgbClr val="0070C0"/>
                 </a:solidFill>
@@ -11056,10 +10926,9 @@
           </a:lstStyle>
           <a:p>
             <a:r>
-              <a:rPr lang="en-GB" dirty="0" smtClean="0"/>
-              <a:t>DORA: Funders adoption</a:t>
-            </a:r>
-            <a:endParaRPr lang="en-GB" dirty="0"/>
+              <a:rPr lang="en-GB" dirty="0"/>
+              <a:t>DORA: Funder adoption</a:t>
+            </a:r>
           </a:p>
         </p:txBody>
       </p:sp>
@@ -11093,23 +10962,15 @@
           <a:p>
             <a:r>
               <a:rPr lang="en-GB" sz="1400" dirty="0"/>
-              <a:t>CREDITS </a:t>
-            </a:r>
-            <a:r>
-              <a:rPr lang="en-GB" sz="1400" dirty="0" smtClean="0"/>
-              <a:t>[</a:t>
-            </a:r>
-            <a:r>
-              <a:rPr lang="pl-PL" sz="1400" dirty="0" smtClean="0"/>
+              <a:t>CREDITS [</a:t>
+            </a:r>
+            <a:r>
+              <a:rPr lang="pl-PL" sz="1400" dirty="0"/>
               <a:t>5</a:t>
             </a:r>
             <a:r>
-              <a:rPr lang="en-GB" sz="1400" dirty="0" smtClean="0"/>
-              <a:t>] </a:t>
-            </a:r>
-            <a:r>
               <a:rPr lang="en-GB" sz="1400" dirty="0"/>
-              <a:t>CC BY</a:t>
+              <a:t>] CC BY</a:t>
             </a:r>
           </a:p>
         </p:txBody>
@@ -11125,13 +10986,6 @@
     <a:masterClrMapping/>
   </p:clrMapOvr>
   <p:transition spd="med"/>
-  <p:timing>
-    <p:tnLst>
-      <p:par>
-        <p:cTn id="1" dur="indefinite" restart="never" nodeType="tmRoot"/>
-      </p:par>
-    </p:tnLst>
-  </p:timing>
 </p:sld>
 </file>
 
@@ -11168,10 +11022,9 @@
           <a:lstStyle/>
           <a:p>
             <a:r>
-              <a:rPr lang="en-GB" dirty="0" smtClean="0"/>
+              <a:rPr lang="en-GB" dirty="0"/>
               <a:t>Narrative CV</a:t>
             </a:r>
-            <a:endParaRPr lang="en-GB" dirty="0"/>
           </a:p>
         </p:txBody>
       </p:sp>
@@ -11227,7 +11080,7 @@
             <a:pPr marL="0" indent="0">
               <a:buNone/>
             </a:pPr>
-            <a:endParaRPr lang="en-GB" dirty="0" smtClean="0"/>
+            <a:endParaRPr lang="en-GB" dirty="0"/>
           </a:p>
           <a:p>
             <a:pPr marL="0" indent="0">
@@ -11247,13 +11100,6 @@
   <p:clrMapOvr>
     <a:masterClrMapping/>
   </p:clrMapOvr>
-  <p:timing>
-    <p:tnLst>
-      <p:par>
-        <p:cTn id="1" dur="indefinite" restart="never" nodeType="tmRoot"/>
-      </p:par>
-    </p:tnLst>
-  </p:timing>
 </p:sld>
 </file>
 
@@ -11290,10 +11136,9 @@
           <a:lstStyle/>
           <a:p>
             <a:r>
-              <a:rPr lang="en-GB" dirty="0" smtClean="0"/>
+              <a:rPr lang="en-GB" dirty="0"/>
               <a:t>Narrative CV</a:t>
             </a:r>
-            <a:endParaRPr lang="en-GB" dirty="0"/>
           </a:p>
         </p:txBody>
       </p:sp>
@@ -11315,68 +11160,20 @@
           <a:lstStyle/>
           <a:p>
             <a:r>
-              <a:rPr lang="en-GB" dirty="0" smtClean="0"/>
-              <a:t>A </a:t>
-            </a:r>
-            <a:r>
               <a:rPr lang="en-GB" dirty="0"/>
-              <a:t>broad definition of ‘output’ is </a:t>
-            </a:r>
-            <a:r>
-              <a:rPr lang="en-GB" dirty="0" smtClean="0"/>
-              <a:t>used, such </a:t>
-            </a:r>
+              <a:t>A broad definition of ‘output’ is used, such as datasets, patents and software.*</a:t>
+            </a:r>
+          </a:p>
+          <a:p>
             <a:r>
               <a:rPr lang="en-GB" dirty="0"/>
-              <a:t>as datasets, patents and software.</a:t>
-            </a:r>
-          </a:p>
-          <a:p>
-            <a:r>
-              <a:rPr lang="en-GB" dirty="0" smtClean="0"/>
-              <a:t>Special </a:t>
-            </a:r>
-            <a:r>
-              <a:rPr lang="en-GB" dirty="0"/>
-              <a:t>attention is paid to Open </a:t>
-            </a:r>
-            <a:r>
-              <a:rPr lang="en-GB" dirty="0" smtClean="0"/>
-              <a:t>Science, which outputs </a:t>
-            </a:r>
-            <a:r>
-              <a:rPr lang="en-GB" dirty="0"/>
-              <a:t>are openly available</a:t>
-            </a:r>
-            <a:r>
-              <a:rPr lang="en-GB" dirty="0" smtClean="0"/>
-              <a:t>.</a:t>
-            </a:r>
-          </a:p>
-          <a:p>
-            <a:r>
-              <a:rPr lang="en-US" dirty="0" smtClean="0"/>
-              <a:t>New metrics: retweets, </a:t>
-            </a:r>
+              <a:t>Special attention is paid to Open Science, which outputs are openly available.</a:t>
+            </a:r>
+          </a:p>
+          <a:p>
             <a:r>
               <a:rPr lang="en-US" dirty="0"/>
-              <a:t>online views and </a:t>
-            </a:r>
-            <a:r>
-              <a:rPr lang="en-US" dirty="0" smtClean="0"/>
-              <a:t>downloads</a:t>
-            </a:r>
-            <a:r>
-              <a:rPr lang="en-US" smtClean="0"/>
-              <a:t>, discussions, </a:t>
-            </a:r>
-            <a:r>
-              <a:rPr lang="en-US" dirty="0" smtClean="0"/>
-              <a:t>presence in mass </a:t>
-            </a:r>
-            <a:r>
-              <a:rPr lang="en-US" dirty="0"/>
-              <a:t>media technology platforms</a:t>
+              <a:t>New metrics: retweets, online views and downloads, discussions, presence in mass media technology platforms</a:t>
             </a:r>
             <a:endParaRPr lang="en-GB" dirty="0"/>
           </a:p>
@@ -11385,6 +11182,21 @@
               <a:buNone/>
             </a:pPr>
             <a:endParaRPr lang="en-GB" dirty="0"/>
+          </a:p>
+          <a:p>
+            <a:pPr marL="0" indent="0">
+              <a:buNone/>
+            </a:pPr>
+            <a:endParaRPr lang="en-GB" dirty="0"/>
+          </a:p>
+          <a:p>
+            <a:pPr marL="0" indent="0">
+              <a:buNone/>
+            </a:pPr>
+            <a:r>
+              <a:rPr lang="en-GB" dirty="0"/>
+              <a:t>*UK REF also assesses research outputs, not just publications.</a:t>
+            </a:r>
           </a:p>
         </p:txBody>
       </p:sp>
@@ -11398,13 +11210,6 @@
   <p:clrMapOvr>
     <a:masterClrMapping/>
   </p:clrMapOvr>
-  <p:timing>
-    <p:tnLst>
-      <p:par>
-        <p:cTn id="1" dur="indefinite" restart="never" nodeType="tmRoot"/>
-      </p:par>
-    </p:tnLst>
-  </p:timing>
 </p:sld>
 </file>
 
@@ -11441,27 +11246,27 @@
           <a:lstStyle/>
           <a:p>
             <a:r>
-              <a:rPr lang="en-GB" dirty="0" smtClean="0"/>
+              <a:rPr lang="en-GB" dirty="0"/>
               <a:t>It is </a:t>
             </a:r>
             <a:r>
-              <a:rPr lang="pl-PL" dirty="0" smtClean="0"/>
+              <a:rPr lang="pl-PL" dirty="0"/>
               <a:t>easier to </a:t>
             </a:r>
             <a:r>
-              <a:rPr lang="pl-PL" smtClean="0"/>
+              <a:rPr lang="pl-PL"/>
               <a:t>be prep</a:t>
             </a:r>
             <a:r>
-              <a:rPr lang="en-GB" smtClean="0"/>
+              <a:rPr lang="en-GB"/>
               <a:t>a</a:t>
             </a:r>
             <a:r>
-              <a:rPr lang="pl-PL" smtClean="0"/>
+              <a:rPr lang="pl-PL"/>
               <a:t>red </a:t>
             </a:r>
             <a:r>
-              <a:rPr lang="pl-PL" dirty="0" smtClean="0"/>
+              <a:rPr lang="pl-PL" dirty="0"/>
               <a:t>than to fake it</a:t>
             </a:r>
             <a:endParaRPr lang="en-GB" dirty="0"/>
@@ -11486,25 +11291,24 @@
           <a:lstStyle/>
           <a:p>
             <a:r>
-              <a:rPr lang="en-GB" dirty="0" smtClean="0"/>
-              <a:t>It takes time to make the outputs public</a:t>
-            </a:r>
-          </a:p>
-          <a:p>
-            <a:r>
-              <a:rPr lang="en-GB" dirty="0" smtClean="0"/>
+              <a:rPr lang="en-GB" dirty="0"/>
+              <a:t>It takes time to make research outputs public</a:t>
+            </a:r>
+          </a:p>
+          <a:p>
+            <a:r>
+              <a:rPr lang="en-GB" dirty="0"/>
               <a:t>The quality of open outputs is easy to assess</a:t>
             </a:r>
           </a:p>
           <a:p>
-            <a:endParaRPr lang="en-GB" dirty="0" smtClean="0"/>
-          </a:p>
-          <a:p>
-            <a:r>
-              <a:rPr lang="en-GB" dirty="0" smtClean="0"/>
+            <a:endParaRPr lang="en-GB" dirty="0"/>
+          </a:p>
+          <a:p>
+            <a:r>
+              <a:rPr lang="en-GB" dirty="0"/>
               <a:t>Timestamps </a:t>
             </a:r>
-            <a:endParaRPr lang="en-GB" dirty="0"/>
           </a:p>
           <a:p>
             <a:pPr marL="0" indent="0">
@@ -11524,13 +11328,6 @@
   <p:clrMapOvr>
     <a:masterClrMapping/>
   </p:clrMapOvr>
-  <p:timing>
-    <p:tnLst>
-      <p:par>
-        <p:cTn id="1" dur="indefinite" restart="never" nodeType="tmRoot"/>
-      </p:par>
-    </p:tnLst>
-  </p:timing>
 </p:sld>
 </file>
 
@@ -11601,10 +11398,9 @@
               <a:buNone/>
             </a:pPr>
             <a:r>
-              <a:rPr lang="en-GB" sz="4000" dirty="0" smtClean="0"/>
+              <a:rPr lang="en-GB" sz="4000" dirty="0"/>
               <a:t>Why you should do it</a:t>
             </a:r>
-            <a:endParaRPr lang="en-GB" sz="4000" dirty="0"/>
           </a:p>
         </p:txBody>
       </p:sp>
@@ -11618,13 +11414,6 @@
   <p:clrMapOvr>
     <a:masterClrMapping/>
   </p:clrMapOvr>
-  <p:timing>
-    <p:tnLst>
-      <p:par>
-        <p:cTn id="1" dur="indefinite" restart="never" nodeType="tmRoot"/>
-      </p:par>
-    </p:tnLst>
-  </p:timing>
 </p:sld>
 </file>
 
@@ -11661,7 +11450,7 @@
           <a:lstStyle/>
           <a:p>
             <a:r>
-              <a:rPr lang="en-GB" smtClean="0"/>
+              <a:rPr lang="en-GB"/>
               <a:t>Exercise – lottery winner</a:t>
             </a:r>
             <a:endParaRPr lang="en-GB" dirty="0"/>
@@ -11748,13 +11537,6 @@
   <p:clrMapOvr>
     <a:masterClrMapping/>
   </p:clrMapOvr>
-  <p:timing>
-    <p:tnLst>
-      <p:par>
-        <p:cTn id="1" dur="indefinite" restart="never" nodeType="tmRoot"/>
-      </p:par>
-    </p:tnLst>
-  </p:timing>
 </p:sld>
 </file>
 
@@ -11791,7 +11573,7 @@
           <a:lstStyle/>
           <a:p>
             <a:r>
-              <a:rPr lang="en-GB" smtClean="0"/>
+              <a:rPr lang="en-GB"/>
               <a:t>Lottery winner exercise - conclusions</a:t>
             </a:r>
             <a:endParaRPr lang="en-GB" dirty="0"/>
@@ -11825,11 +11607,11 @@
               <a:buNone/>
             </a:pPr>
             <a:r>
-              <a:rPr lang="en-GB" sz="4000" dirty="0" smtClean="0"/>
+              <a:rPr lang="en-GB" sz="4000" dirty="0"/>
               <a:t>Good data management</a:t>
             </a:r>
             <a:r>
-              <a:rPr lang="pl-PL" sz="4000" dirty="0" smtClean="0"/>
+              <a:rPr lang="pl-PL" sz="4000" dirty="0"/>
               <a:t>:</a:t>
             </a:r>
           </a:p>
@@ -11839,18 +11621,18 @@
               <a:buChar char="-"/>
             </a:pPr>
             <a:r>
-              <a:rPr lang="en-GB" sz="4000" dirty="0" smtClean="0"/>
+              <a:rPr lang="en-GB" sz="4000" dirty="0"/>
               <a:t>improve</a:t>
             </a:r>
             <a:r>
-              <a:rPr lang="pl-PL" sz="4000" dirty="0" smtClean="0"/>
+              <a:rPr lang="pl-PL" sz="4000" dirty="0"/>
               <a:t>s</a:t>
             </a:r>
             <a:r>
-              <a:rPr lang="en-GB" sz="4000" dirty="0" smtClean="0"/>
+              <a:rPr lang="en-GB" sz="4000" dirty="0"/>
               <a:t> productivity</a:t>
             </a:r>
-            <a:endParaRPr lang="pl-PL" sz="4000" dirty="0" smtClean="0"/>
+            <a:endParaRPr lang="pl-PL" sz="4000" dirty="0"/>
           </a:p>
           <a:p>
             <a:pPr>
@@ -11858,18 +11640,18 @@
               <a:buChar char="-"/>
             </a:pPr>
             <a:r>
-              <a:rPr lang="en-GB" sz="4000" dirty="0" smtClean="0"/>
+              <a:rPr lang="en-GB" sz="4000" dirty="0"/>
               <a:t>assure</a:t>
             </a:r>
             <a:r>
-              <a:rPr lang="pl-PL" sz="4000" dirty="0" smtClean="0"/>
+              <a:rPr lang="pl-PL" sz="4000" dirty="0"/>
               <a:t>s</a:t>
             </a:r>
             <a:r>
-              <a:rPr lang="en-GB" sz="4000" dirty="0" smtClean="0"/>
+              <a:rPr lang="en-GB" sz="4000" dirty="0"/>
               <a:t> safety of your research</a:t>
             </a:r>
-            <a:endParaRPr lang="pl-PL" sz="4000" dirty="0" smtClean="0"/>
+            <a:endParaRPr lang="pl-PL" sz="4000" dirty="0"/>
           </a:p>
           <a:p>
             <a:pPr>
@@ -11877,10 +11659,10 @@
               <a:buChar char="-"/>
             </a:pPr>
             <a:r>
-              <a:rPr lang="en-GB" sz="4000" dirty="0" smtClean="0"/>
+              <a:rPr lang="en-GB" sz="4000" dirty="0"/>
               <a:t>speeds up induction</a:t>
             </a:r>
-            <a:endParaRPr lang="pl-PL" sz="4000" dirty="0" smtClean="0"/>
+            <a:endParaRPr lang="pl-PL" sz="4000" dirty="0"/>
           </a:p>
           <a:p>
             <a:pPr>
@@ -11888,7 +11670,7 @@
               <a:buChar char="-"/>
             </a:pPr>
             <a:r>
-              <a:rPr lang="en-GB" sz="4000" dirty="0" smtClean="0"/>
+              <a:rPr lang="en-GB" sz="4000" dirty="0"/>
               <a:t>makes it easier to generate public outputs</a:t>
             </a:r>
             <a:endParaRPr lang="pl-PL" sz="4000" dirty="0"/>
@@ -11905,13 +11687,6 @@
   <p:clrMapOvr>
     <a:masterClrMapping/>
   </p:clrMapOvr>
-  <p:timing>
-    <p:tnLst>
-      <p:par>
-        <p:cTn id="1" dur="indefinite" restart="never" nodeType="tmRoot"/>
-      </p:par>
-    </p:tnLst>
-  </p:timing>
 </p:sld>
 </file>
 
@@ -11987,21 +11762,21 @@
           </a:p>
           <a:p>
             <a:r>
-              <a:rPr lang="en-GB" sz="4000" dirty="0" smtClean="0"/>
+              <a:rPr lang="en-GB" sz="4000" dirty="0"/>
               <a:t>Being FAIR</a:t>
             </a:r>
             <a:endParaRPr lang="pl-PL" sz="4000" dirty="0"/>
           </a:p>
           <a:p>
             <a:r>
-              <a:rPr lang="en-GB" sz="4000" dirty="0" smtClean="0"/>
-              <a:t>Tools for oracles and overlords</a:t>
+              <a:rPr lang="en-GB" sz="4000" dirty="0"/>
+              <a:t>Tools for overlords</a:t>
             </a:r>
             <a:endParaRPr lang="pl-PL" sz="4000" dirty="0"/>
           </a:p>
           <a:p>
             <a:r>
-              <a:rPr lang="en-GB" sz="4000" dirty="0" smtClean="0"/>
+              <a:rPr lang="en-GB" sz="4000" dirty="0"/>
               <a:t>Public repositories</a:t>
             </a:r>
             <a:endParaRPr lang="pl-PL" sz="4000" dirty="0"/>
@@ -12009,19 +11784,14 @@
           <a:p>
             <a:r>
               <a:rPr lang="en-GB" sz="4000" dirty="0"/>
-              <a:t>It is all about </a:t>
-            </a:r>
-            <a:r>
-              <a:rPr lang="en-GB" sz="4000" dirty="0" smtClean="0"/>
-              <a:t>planning</a:t>
-            </a:r>
-          </a:p>
-          <a:p>
-            <a:r>
-              <a:rPr lang="en-GB" sz="4000" dirty="0" smtClean="0"/>
+              <a:t>It is all about planning</a:t>
+            </a:r>
+          </a:p>
+          <a:p>
+            <a:r>
+              <a:rPr lang="en-GB" sz="4000" dirty="0"/>
               <a:t>Wrap up</a:t>
             </a:r>
-            <a:endParaRPr lang="en-GB" sz="4000" dirty="0"/>
           </a:p>
         </p:txBody>
       </p:sp>
@@ -12035,13 +11805,6 @@
   <p:clrMapOvr>
     <a:masterClrMapping/>
   </p:clrMapOvr>
-  <p:timing>
-    <p:tnLst>
-      <p:par>
-        <p:cTn id="1" dur="indefinite" restart="never" nodeType="tmRoot"/>
-      </p:par>
-    </p:tnLst>
-  </p:timing>
 </p:sld>
 </file>
 
@@ -12083,10 +11846,9 @@
           <a:lstStyle/>
           <a:p>
             <a:r>
-              <a:rPr lang="en-GB" dirty="0" smtClean="0"/>
+              <a:rPr lang="en-GB" dirty="0"/>
               <a:t>Credits</a:t>
             </a:r>
-            <a:endParaRPr lang="en-GB" dirty="0"/>
           </a:p>
         </p:txBody>
       </p:sp>
@@ -12123,88 +11885,58 @@
           <a:lstStyle/>
           <a:p>
             <a:r>
-              <a:rPr lang="pl-PL" sz="1400" dirty="0" smtClean="0"/>
-              <a:t>[</a:t>
-            </a:r>
-            <a:r>
               <a:rPr lang="pl-PL" sz="1400" dirty="0"/>
-              <a:t>1] Gema Bueno de la Fuente, “What is Open Science? Introduction”, </a:t>
+              <a:t>[1] Gema Bueno de la Fuente, “What is Open Science? Introduction”, </a:t>
             </a:r>
             <a:r>
               <a:rPr lang="pl-PL" sz="1400" dirty="0">
                 <a:hlinkClick r:id="rId2"/>
               </a:rPr>
-              <a:t>https://</a:t>
-            </a:r>
-            <a:r>
-              <a:rPr lang="pl-PL" sz="1400" dirty="0" smtClean="0">
-                <a:hlinkClick r:id="rId2"/>
-              </a:rPr>
-              <a:t>www.fosteropenscience.eu/content/what-open-science-introduction</a:t>
-            </a:r>
-            <a:r>
-              <a:rPr lang="en-GB" sz="1400" dirty="0" smtClean="0"/>
+              <a:t>https://www.fosteropenscience.eu/content/what-open-science-introduction</a:t>
+            </a:r>
+            <a:r>
+              <a:rPr lang="en-GB" sz="1400" dirty="0"/>
               <a:t> </a:t>
             </a:r>
             <a:endParaRPr lang="pl-PL" sz="1400" dirty="0"/>
           </a:p>
           <a:p>
             <a:r>
-              <a:rPr lang="pl-PL" sz="1400" dirty="0" smtClean="0"/>
+              <a:rPr lang="pl-PL" sz="1400" dirty="0"/>
               <a:t>[2] </a:t>
             </a:r>
             <a:r>
-              <a:rPr lang="en-GB" sz="1400" dirty="0" smtClean="0"/>
+              <a:rPr lang="en-GB" sz="1400" dirty="0"/>
               <a:t>Photo</a:t>
             </a:r>
             <a:r>
-              <a:rPr lang="pl-PL" sz="1400" dirty="0" smtClean="0"/>
+              <a:rPr lang="pl-PL" sz="1400" dirty="0"/>
               <a:t>s Unsplash</a:t>
             </a:r>
             <a:r>
-              <a:rPr lang="en-GB" sz="1400" dirty="0" smtClean="0"/>
+              <a:rPr lang="en-GB" sz="1400" dirty="0"/>
               <a:t> by</a:t>
             </a:r>
             <a:r>
-              <a:rPr lang="pl-PL" sz="1400" dirty="0" smtClean="0"/>
+              <a:rPr lang="pl-PL" sz="1400" dirty="0"/>
               <a:t>:</a:t>
             </a:r>
             <a:r>
-              <a:rPr lang="en-GB" sz="1400" dirty="0" smtClean="0"/>
+              <a:rPr lang="en-GB" sz="1400" dirty="0"/>
               <a:t> </a:t>
             </a:r>
-            <a:r>
-              <a:rPr lang="pl-PL" sz="1400" dirty="0" smtClean="0"/>
-              <a:t/>
-            </a:r>
             <a:br>
-              <a:rPr lang="pl-PL" sz="1400" dirty="0" smtClean="0"/>
+              <a:rPr lang="pl-PL" sz="1400" dirty="0"/>
             </a:br>
             <a:r>
-              <a:rPr lang="en-GB" sz="1400" dirty="0" smtClean="0"/>
+              <a:rPr lang="en-GB" sz="1400" dirty="0"/>
               <a:t>Evangeline Shaw </a:t>
-            </a:r>
-            <a:r>
-              <a:rPr lang="pl-PL" sz="1400" dirty="0" smtClean="0">
-                <a:hlinkClick r:id="rId3"/>
-              </a:rPr>
-              <a:t>https</a:t>
             </a:r>
             <a:r>
               <a:rPr lang="pl-PL" sz="1400" dirty="0">
                 <a:hlinkClick r:id="rId3"/>
               </a:rPr>
-              <a:t>://</a:t>
-            </a:r>
-            <a:r>
-              <a:rPr lang="pl-PL" sz="1400" dirty="0" smtClean="0">
-                <a:hlinkClick r:id="rId3"/>
-              </a:rPr>
-              <a:t>unsplash.com/photos/nwLTVwb7DbU</a:t>
-            </a:r>
-            <a:r>
-              <a:rPr lang="pl-PL" sz="1400" dirty="0"/>
-              <a:t/>
+              <a:t>https://unsplash.com/photos/nwLTVwb7DbU</a:t>
             </a:r>
             <a:br>
               <a:rPr lang="pl-PL" sz="1400" dirty="0"/>
@@ -12214,34 +11946,18 @@
               <a:t>Alexei </a:t>
             </a:r>
             <a:r>
-              <a:rPr lang="en-GB" sz="1400" dirty="0" err="1" smtClean="0"/>
+              <a:rPr lang="en-GB" sz="1400" dirty="0" err="1"/>
               <a:t>Scutar</a:t>
             </a:r>
             <a:r>
-              <a:rPr lang="pl-PL" sz="1400" dirty="0" smtClean="0"/>
+              <a:rPr lang="pl-PL" sz="1400" dirty="0"/>
               <a:t> </a:t>
-            </a:r>
-            <a:r>
-              <a:rPr lang="pl-PL" sz="1400" dirty="0" smtClean="0">
-                <a:hlinkClick r:id="rId4"/>
-              </a:rPr>
-              <a:t>https</a:t>
             </a:r>
             <a:r>
               <a:rPr lang="pl-PL" sz="1400" dirty="0">
                 <a:hlinkClick r:id="rId4"/>
               </a:rPr>
-              <a:t>://</a:t>
-            </a:r>
-            <a:r>
-              <a:rPr lang="pl-PL" sz="1400" dirty="0" smtClean="0">
-                <a:hlinkClick r:id="rId4"/>
-              </a:rPr>
-              <a:t>unsplash.com/photos/5Zg64OwXJg8</a:t>
-            </a:r>
-            <a:r>
-              <a:rPr lang="pl-PL" sz="1400" dirty="0"/>
-              <a:t/>
+              <a:t>https://unsplash.com/photos/5Zg64OwXJg8</a:t>
             </a:r>
             <a:br>
               <a:rPr lang="pl-PL" sz="1400" dirty="0"/>
@@ -12251,87 +11967,53 @@
               <a:t>Markus </a:t>
             </a:r>
             <a:r>
-              <a:rPr lang="en-GB" sz="1400" dirty="0" err="1" smtClean="0"/>
+              <a:rPr lang="en-GB" sz="1400" dirty="0" err="1"/>
               <a:t>Spiske</a:t>
             </a:r>
             <a:r>
-              <a:rPr lang="pl-PL" sz="1400" dirty="0" smtClean="0"/>
+              <a:rPr lang="pl-PL" sz="1400" dirty="0"/>
               <a:t> </a:t>
-            </a:r>
-            <a:r>
-              <a:rPr lang="pl-PL" sz="1400" dirty="0" smtClean="0">
-                <a:hlinkClick r:id="rId5"/>
-              </a:rPr>
-              <a:t>https</a:t>
             </a:r>
             <a:r>
               <a:rPr lang="pl-PL" sz="1400" dirty="0">
                 <a:hlinkClick r:id="rId5"/>
               </a:rPr>
-              <a:t>://</a:t>
-            </a:r>
-            <a:r>
-              <a:rPr lang="pl-PL" sz="1400" dirty="0" smtClean="0">
-                <a:hlinkClick r:id="rId5"/>
-              </a:rPr>
-              <a:t>unsplash.com/photos/7PMGUqYQpYc</a:t>
-            </a:r>
-            <a:endParaRPr lang="pl-PL" sz="1400" dirty="0" smtClean="0"/>
-          </a:p>
-          <a:p>
-            <a:r>
-              <a:rPr lang="pl-PL" sz="1400" dirty="0" smtClean="0"/>
-              <a:t>[3] Photo Jonathunder, Medal</a:t>
-            </a:r>
+              <a:t>https://unsplash.com/photos/7PMGUqYQpYc</a:t>
+            </a:r>
+            <a:endParaRPr lang="pl-PL" sz="1400" dirty="0"/>
+          </a:p>
+          <a:p>
             <a:r>
               <a:rPr lang="pl-PL" sz="1400" dirty="0"/>
-              <a:t>: Erik Lindberg (1873-1966) - </a:t>
-            </a:r>
-            <a:r>
-              <a:rPr lang="pl-PL" sz="1400" dirty="0" smtClean="0"/>
-              <a:t>NobelPrize.JPG</a:t>
-            </a:r>
-            <a:r>
-              <a:rPr lang="pl-PL" sz="1400" dirty="0"/>
-              <a:t>, PD-US, </a:t>
+              <a:t>[3] Photo Jonathunder, Medal: Erik Lindberg (1873-1966) - NobelPrize.JPG, PD-US, </a:t>
             </a:r>
             <a:r>
               <a:rPr lang="pl-PL" sz="1400" dirty="0">
                 <a:hlinkClick r:id="rId6"/>
               </a:rPr>
-              <a:t>https://</a:t>
-            </a:r>
-            <a:r>
-              <a:rPr lang="pl-PL" sz="1400" dirty="0" smtClean="0">
-                <a:hlinkClick r:id="rId6"/>
-              </a:rPr>
-              <a:t>en.wikipedia.org/w/index.php?curid=58432969</a:t>
-            </a:r>
-            <a:endParaRPr lang="pl-PL" sz="1400" dirty="0" smtClean="0"/>
-          </a:p>
-          <a:p>
-            <a:r>
-              <a:rPr lang="pl-PL" sz="1400" dirty="0" smtClean="0"/>
+              <a:t>https://en.wikipedia.org/w/index.php?curid=58432969</a:t>
+            </a:r>
+            <a:endParaRPr lang="pl-PL" sz="1400" dirty="0"/>
+          </a:p>
+          <a:p>
+            <a:r>
+              <a:rPr lang="pl-PL" sz="1400" dirty="0"/>
               <a:t>[4] </a:t>
             </a:r>
             <a:r>
-              <a:rPr lang="en-GB" sz="1400" dirty="0" smtClean="0"/>
+              <a:rPr lang="en-GB" sz="1400" dirty="0"/>
               <a:t>Photo</a:t>
             </a:r>
             <a:r>
-              <a:rPr lang="pl-PL" sz="1400" dirty="0" smtClean="0"/>
-              <a:t> </a:t>
-            </a:r>
-            <a:r>
               <a:rPr lang="pl-PL" sz="1400" dirty="0"/>
-              <a:t>Unsplash</a:t>
+              <a:t> Unsplash</a:t>
             </a:r>
             <a:r>
               <a:rPr lang="en-GB" sz="1400" dirty="0"/>
               <a:t> by</a:t>
             </a:r>
             <a:r>
-              <a:rPr lang="pl-PL" sz="1400" dirty="0" smtClean="0"/>
+              <a:rPr lang="pl-PL" sz="1400" dirty="0"/>
               <a:t>: </a:t>
             </a:r>
             <a:r>
@@ -12343,45 +12025,29 @@
               <a:t> A</a:t>
             </a:r>
             <a:r>
-              <a:rPr lang="pl-PL" sz="1400" dirty="0" smtClean="0"/>
+              <a:rPr lang="pl-PL" sz="1400" dirty="0"/>
               <a:t> </a:t>
             </a:r>
             <a:r>
               <a:rPr lang="pl-PL" sz="1400" dirty="0">
                 <a:hlinkClick r:id="rId7"/>
               </a:rPr>
-              <a:t>https://</a:t>
-            </a:r>
-            <a:r>
-              <a:rPr lang="pl-PL" sz="1400" dirty="0" smtClean="0">
-                <a:hlinkClick r:id="rId7"/>
-              </a:rPr>
-              <a:t>unsplash.com/photos/6ZR-f5bkrGE</a:t>
-            </a:r>
-            <a:endParaRPr lang="pl-PL" sz="1400" dirty="0" smtClean="0"/>
+              <a:t>https://unsplash.com/photos/6ZR-f5bkrGE</a:t>
+            </a:r>
+            <a:endParaRPr lang="pl-PL" sz="1400" dirty="0"/>
           </a:p>
           <a:p>
             <a:r>
               <a:rPr lang="pl-PL" sz="1400" dirty="0"/>
-              <a:t>[5] </a:t>
-            </a:r>
-            <a:r>
-              <a:rPr lang="pl-PL" sz="1400" dirty="0" smtClean="0"/>
-              <a:t>DORA </a:t>
+              <a:t>[5] DORA </a:t>
             </a:r>
             <a:r>
               <a:rPr lang="pl-PL" sz="1400" dirty="0">
                 <a:hlinkClick r:id="rId8"/>
               </a:rPr>
-              <a:t>https://sfdora.org/resource/dora-slide-presentations</a:t>
-            </a:r>
-            <a:r>
-              <a:rPr lang="pl-PL" sz="1400" dirty="0" smtClean="0">
-                <a:hlinkClick r:id="rId8"/>
-              </a:rPr>
-              <a:t>/</a:t>
-            </a:r>
-            <a:endParaRPr lang="en-GB" sz="1400" dirty="0" smtClean="0"/>
+              <a:t>https://sfdora.org/resource/dora-slide-presentations/</a:t>
+            </a:r>
+            <a:endParaRPr lang="en-GB" sz="1400" dirty="0"/>
           </a:p>
           <a:p>
             <a:endParaRPr lang="en-GB" sz="1400" dirty="0"/>
@@ -12391,7 +12057,7 @@
               <a:buNone/>
             </a:pPr>
             <a:r>
-              <a:rPr lang="en-GB" sz="2000" dirty="0" smtClean="0"/>
+              <a:rPr lang="en-GB" sz="2000" dirty="0"/>
               <a:t>Funding</a:t>
             </a:r>
           </a:p>
@@ -12400,20 +12066,16 @@
               <a:buNone/>
             </a:pPr>
             <a:r>
-              <a:rPr lang="en-GB" sz="1400" dirty="0" smtClean="0"/>
+              <a:rPr lang="en-GB" sz="1400" dirty="0"/>
               <a:t>Ed-</a:t>
             </a:r>
             <a:r>
-              <a:rPr lang="en-GB" sz="1400" dirty="0" err="1" smtClean="0"/>
+              <a:rPr lang="en-GB" sz="1400" dirty="0" err="1"/>
               <a:t>DaSH</a:t>
             </a:r>
             <a:r>
-              <a:rPr lang="en-GB" sz="1400" dirty="0" smtClean="0"/>
-              <a:t> </a:t>
-            </a:r>
-            <a:r>
               <a:rPr lang="en-GB" sz="1400" dirty="0"/>
-              <a:t>is a Data Science training programme for Health and Biosciences. This work was supported by UK Research and Innovation [grant number MR/V039075/1].</a:t>
+              <a:t> is a Data Science training programme for Health and Biosciences. This work was supported by UK Research and Innovation [grant number MR/V039075/1].</a:t>
             </a:r>
           </a:p>
           <a:p>
@@ -12421,28 +12083,16 @@
               <a:buNone/>
             </a:pPr>
             <a:r>
-              <a:rPr lang="en-GB" sz="1400" dirty="0" smtClean="0">
-                <a:hlinkClick r:id="rId9"/>
-              </a:rPr>
-              <a:t>https</a:t>
-            </a:r>
-            <a:r>
               <a:rPr lang="en-GB" sz="1400" dirty="0">
                 <a:hlinkClick r:id="rId9"/>
               </a:rPr>
-              <a:t>://edcarp.github.io/Ed-DaSH</a:t>
-            </a:r>
-            <a:r>
-              <a:rPr lang="en-GB" sz="1400" dirty="0" smtClean="0">
-                <a:hlinkClick r:id="rId9"/>
-              </a:rPr>
-              <a:t>/</a:t>
-            </a:r>
-            <a:r>
-              <a:rPr lang="en-GB" sz="1400" dirty="0" smtClean="0"/>
+              <a:t>https://edcarp.github.io/Ed-DaSH/</a:t>
+            </a:r>
+            <a:r>
+              <a:rPr lang="en-GB" sz="1400" dirty="0"/>
               <a:t> </a:t>
             </a:r>
-            <a:endParaRPr lang="pl-PL" sz="1400" dirty="0" smtClean="0"/>
+            <a:endParaRPr lang="pl-PL" sz="1400" dirty="0"/>
           </a:p>
           <a:p>
             <a:endParaRPr lang="pl-PL" sz="1400" dirty="0"/>
@@ -12459,13 +12109,6 @@
   <p:clrMapOvr>
     <a:masterClrMapping/>
   </p:clrMapOvr>
-  <p:timing>
-    <p:tnLst>
-      <p:par>
-        <p:cTn id="1" dur="indefinite" restart="never" nodeType="tmRoot"/>
-      </p:par>
-    </p:tnLst>
-  </p:timing>
 </p:sld>
 </file>
 
@@ -12502,10 +12145,9 @@
           <a:lstStyle/>
           <a:p>
             <a:r>
-              <a:rPr lang="en-GB" dirty="0" smtClean="0"/>
+              <a:rPr lang="en-GB" dirty="0"/>
               <a:t>Better research by better sharing</a:t>
             </a:r>
-            <a:endParaRPr lang="en-GB" dirty="0"/>
           </a:p>
         </p:txBody>
       </p:sp>
@@ -12527,92 +12169,38 @@
           <a:lstStyle/>
           <a:p>
             <a:r>
-              <a:rPr lang="en-GB" sz="3200" dirty="0" smtClean="0"/>
-              <a:t>why </a:t>
-            </a:r>
-            <a:r>
               <a:rPr lang="en-GB" sz="3200" dirty="0"/>
-              <a:t>you should know about Open </a:t>
-            </a:r>
-            <a:r>
-              <a:rPr lang="en-GB" sz="3200" dirty="0" smtClean="0"/>
-              <a:t>Science</a:t>
-            </a:r>
+              <a:t>why you should know about Open Science, FAIR and data management </a:t>
+            </a:r>
+          </a:p>
+          <a:p>
+            <a:endParaRPr lang="en-GB" sz="3200" dirty="0"/>
+          </a:p>
+          <a:p>
             <a:r>
               <a:rPr lang="en-GB" sz="3200" dirty="0"/>
-              <a:t>, FAIR and </a:t>
-            </a:r>
-            <a:r>
-              <a:rPr lang="en-GB" sz="3200" dirty="0" smtClean="0"/>
-              <a:t>data management </a:t>
-            </a:r>
-          </a:p>
-          <a:p>
-            <a:endParaRPr lang="en-GB" sz="3200" dirty="0" smtClean="0"/>
-          </a:p>
-          <a:p>
-            <a:r>
-              <a:rPr lang="en-GB" sz="3200" dirty="0" smtClean="0"/>
-              <a:t>how </a:t>
-            </a:r>
-            <a:r>
-              <a:rPr lang="en-GB" sz="3200" dirty="0"/>
-              <a:t>adoption of </a:t>
-            </a:r>
-            <a:r>
-              <a:rPr lang="en-GB" sz="3200" dirty="0" smtClean="0"/>
-              <a:t>these </a:t>
-            </a:r>
-            <a:r>
-              <a:rPr lang="en-GB" sz="3200" dirty="0"/>
-              <a:t>practices benefits </a:t>
-            </a:r>
-            <a:r>
-              <a:rPr lang="en-GB" sz="3200" dirty="0" smtClean="0"/>
-              <a:t>your </a:t>
-            </a:r>
-            <a:r>
-              <a:rPr lang="en-GB" sz="3200" dirty="0"/>
-              <a:t>group/organization by: </a:t>
-            </a:r>
-            <a:endParaRPr lang="en-GB" sz="3200" dirty="0" smtClean="0"/>
+              <a:t>how adoption of these practices benefits your group/organization by: </a:t>
+            </a:r>
           </a:p>
           <a:p>
             <a:pPr lvl="1"/>
             <a:r>
-              <a:rPr lang="en-GB" sz="2800" dirty="0" smtClean="0"/>
-              <a:t>improving </a:t>
-            </a:r>
-            <a:r>
               <a:rPr lang="en-GB" sz="2800" dirty="0"/>
-              <a:t>productivity </a:t>
-            </a:r>
-            <a:endParaRPr lang="en-GB" sz="2800" dirty="0" smtClean="0"/>
+              <a:t>improving productivity </a:t>
+            </a:r>
           </a:p>
           <a:p>
             <a:pPr lvl="1"/>
             <a:r>
-              <a:rPr lang="en-GB" sz="2800" dirty="0" smtClean="0"/>
-              <a:t>speeding </a:t>
-            </a:r>
-            <a:r>
               <a:rPr lang="en-GB" sz="2800" dirty="0"/>
-              <a:t>up </a:t>
-            </a:r>
-            <a:r>
-              <a:rPr lang="en-GB" sz="2800" dirty="0" smtClean="0"/>
-              <a:t>inductions</a:t>
+              <a:t>speeding up inductions</a:t>
             </a:r>
           </a:p>
           <a:p>
             <a:pPr lvl="1"/>
             <a:r>
-              <a:rPr lang="en-GB" sz="2800" dirty="0" smtClean="0"/>
-              <a:t>helping </a:t>
-            </a:r>
-            <a:r>
               <a:rPr lang="en-GB" sz="2800" dirty="0"/>
-              <a:t>with your managerial responsibilities</a:t>
+              <a:t>helping with your managerial responsibilities</a:t>
             </a:r>
           </a:p>
         </p:txBody>
@@ -12627,13 +12215,6 @@
   <p:clrMapOvr>
     <a:masterClrMapping/>
   </p:clrMapOvr>
-  <p:timing>
-    <p:tnLst>
-      <p:par>
-        <p:cTn id="1" dur="indefinite" restart="never" nodeType="tmRoot"/>
-      </p:par>
-    </p:tnLst>
-  </p:timing>
 </p:sld>
 </file>
 
@@ -12704,10 +12285,9 @@
               <a:buNone/>
             </a:pPr>
             <a:r>
-              <a:rPr lang="en-GB" sz="4000" dirty="0" smtClean="0"/>
+              <a:rPr lang="en-GB" sz="4000" dirty="0"/>
               <a:t>Who we are and what we do</a:t>
             </a:r>
-            <a:endParaRPr lang="en-GB" sz="4000" dirty="0"/>
           </a:p>
         </p:txBody>
       </p:sp>
@@ -12721,13 +12301,6 @@
   <p:clrMapOvr>
     <a:masterClrMapping/>
   </p:clrMapOvr>
-  <p:timing>
-    <p:tnLst>
-      <p:par>
-        <p:cTn id="1" dur="indefinite" restart="never" nodeType="tmRoot"/>
-      </p:par>
-    </p:tnLst>
-  </p:timing>
 </p:sld>
 </file>
 
@@ -12800,13 +12373,8 @@
           <a:p>
             <a:r>
               <a:rPr lang="en-GB" dirty="0"/>
-              <a:t>Evolution of </a:t>
-            </a:r>
-            <a:r>
-              <a:rPr lang="en-GB" dirty="0" smtClean="0"/>
-              <a:t>Research</a:t>
-            </a:r>
-            <a:endParaRPr lang="en-GB" dirty="0"/>
+              <a:t>Evolution of Research</a:t>
+            </a:r>
           </a:p>
         </p:txBody>
       </p:sp>
@@ -12875,13 +12443,6 @@
   <p:clrMapOvr>
     <a:masterClrMapping/>
   </p:clrMapOvr>
-  <p:timing>
-    <p:tnLst>
-      <p:par>
-        <p:cTn id="1" dur="indefinite" restart="never" nodeType="tmRoot"/>
-      </p:par>
-    </p:tnLst>
-  </p:timing>
 </p:sld>
 </file>
 
@@ -12965,10 +12526,6 @@
               <a:rPr lang="en-GB" dirty="0"/>
               <a:t>Open science is the movement to make scientific research </a:t>
             </a:r>
-            <a:r>
-              <a:rPr lang="pl-PL" dirty="0"/>
-              <a:t/>
-            </a:r>
             <a:br>
               <a:rPr lang="pl-PL" dirty="0"/>
             </a:br>
@@ -12978,11 +12535,7 @@
             </a:r>
             <a:r>
               <a:rPr lang="en-GB"/>
-              <a:t>of </a:t>
-            </a:r>
-            <a:r>
-              <a:rPr lang="en-GB" smtClean="0"/>
-              <a:t>society</a:t>
+              <a:t>of society</a:t>
             </a:r>
             <a:endParaRPr lang="en-GB" dirty="0"/>
           </a:p>
@@ -13207,7 +12760,7 @@
                 <a14:useLocalDpi xmlns:a14="http://schemas.microsoft.com/office/drawing/2010/main" val="0"/>
               </a:ext>
               <a:ext uri="{96DAC541-7B7A-43D3-8B79-37D633B846F1}">
-                <asvg:svgBlip xmlns:asvg="http://schemas.microsoft.com/office/drawing/2016/SVG/main" xmlns="" r:embed="rId3"/>
+                <asvg:svgBlip xmlns:asvg="http://schemas.microsoft.com/office/drawing/2016/SVG/main" r:embed="rId3"/>
               </a:ext>
             </a:extLst>
           </a:blip>
@@ -13246,7 +12799,7 @@
                 <a14:useLocalDpi xmlns:a14="http://schemas.microsoft.com/office/drawing/2010/main" val="0"/>
               </a:ext>
               <a:ext uri="{96DAC541-7B7A-43D3-8B79-37D633B846F1}">
-                <asvg:svgBlip xmlns:asvg="http://schemas.microsoft.com/office/drawing/2016/SVG/main" xmlns="" r:embed="rId5"/>
+                <asvg:svgBlip xmlns:asvg="http://schemas.microsoft.com/office/drawing/2016/SVG/main" r:embed="rId5"/>
               </a:ext>
             </a:extLst>
           </a:blip>
@@ -13285,7 +12838,7 @@
                 <a14:useLocalDpi xmlns:a14="http://schemas.microsoft.com/office/drawing/2010/main" val="0"/>
               </a:ext>
               <a:ext uri="{96DAC541-7B7A-43D3-8B79-37D633B846F1}">
-                <asvg:svgBlip xmlns:asvg="http://schemas.microsoft.com/office/drawing/2016/SVG/main" xmlns="" r:embed="rId7"/>
+                <asvg:svgBlip xmlns:asvg="http://schemas.microsoft.com/office/drawing/2016/SVG/main" r:embed="rId7"/>
               </a:ext>
             </a:extLst>
           </a:blip>
@@ -13324,7 +12877,7 @@
                 <a14:useLocalDpi xmlns:a14="http://schemas.microsoft.com/office/drawing/2010/main" val="0"/>
               </a:ext>
               <a:ext uri="{96DAC541-7B7A-43D3-8B79-37D633B846F1}">
-                <asvg:svgBlip xmlns:asvg="http://schemas.microsoft.com/office/drawing/2016/SVG/main" xmlns="" r:embed="rId9"/>
+                <asvg:svgBlip xmlns:asvg="http://schemas.microsoft.com/office/drawing/2016/SVG/main" r:embed="rId9"/>
               </a:ext>
             </a:extLst>
           </a:blip>
@@ -13363,7 +12916,7 @@
                 <a14:useLocalDpi xmlns:a14="http://schemas.microsoft.com/office/drawing/2010/main" val="0"/>
               </a:ext>
               <a:ext uri="{96DAC541-7B7A-43D3-8B79-37D633B846F1}">
-                <asvg:svgBlip xmlns:asvg="http://schemas.microsoft.com/office/drawing/2016/SVG/main" xmlns="" r:embed="rId11"/>
+                <asvg:svgBlip xmlns:asvg="http://schemas.microsoft.com/office/drawing/2016/SVG/main" r:embed="rId11"/>
               </a:ext>
             </a:extLst>
           </a:blip>
@@ -13402,7 +12955,7 @@
                 <a14:useLocalDpi xmlns:a14="http://schemas.microsoft.com/office/drawing/2010/main" val="0"/>
               </a:ext>
               <a:ext uri="{96DAC541-7B7A-43D3-8B79-37D633B846F1}">
-                <asvg:svgBlip xmlns:asvg="http://schemas.microsoft.com/office/drawing/2016/SVG/main" xmlns="" r:embed="rId13"/>
+                <asvg:svgBlip xmlns:asvg="http://schemas.microsoft.com/office/drawing/2016/SVG/main" r:embed="rId13"/>
               </a:ext>
             </a:extLst>
           </a:blip>
@@ -13447,20 +13000,12 @@
               </a:lnSpc>
             </a:pPr>
             <a:r>
-              <a:rPr lang="en-GB" sz="2400" b="1" dirty="0" smtClean="0">
-                <a:solidFill>
-                  <a:srgbClr val="0070C0"/>
-                </a:solidFill>
-              </a:rPr>
-              <a:t>Digital </a:t>
-            </a:r>
-            <a:r>
               <a:rPr lang="en-GB" sz="2400" b="1" dirty="0">
                 <a:solidFill>
                   <a:srgbClr val="0070C0"/>
                 </a:solidFill>
               </a:rPr>
-              <a:t>technologies</a:t>
+              <a:t>Digital technologies</a:t>
             </a:r>
             <a:r>
               <a:rPr lang="en-GB" sz="2400" dirty="0">
@@ -13512,13 +13057,6 @@
   <p:clrMapOvr>
     <a:masterClrMapping/>
   </p:clrMapOvr>
-  <p:timing>
-    <p:tnLst>
-      <p:par>
-        <p:cTn id="1" dur="indefinite" restart="never" nodeType="tmRoot"/>
-      </p:par>
-    </p:tnLst>
-  </p:timing>
 </p:sld>
 </file>
 
@@ -13648,13 +13186,6 @@
   <p:clrMapOvr>
     <a:masterClrMapping/>
   </p:clrMapOvr>
-  <p:timing>
-    <p:tnLst>
-      <p:par>
-        <p:cTn id="1" dur="indefinite" restart="never" nodeType="tmRoot"/>
-      </p:par>
-    </p:tnLst>
-  </p:timing>
 </p:sld>
 </file>
 
@@ -13731,7 +13262,7 @@
             </a:pPr>
             <a:r>
               <a:rPr lang="en-GB" dirty="0"/>
-              <a:t>The initiative to move to Open Access publishing is known as </a:t>
+              <a:t>The largest initiative to move to Open Access publishing is known as </a:t>
             </a:r>
             <a:r>
               <a:rPr lang="en-GB" b="1" dirty="0"/>

</xml_diff>

<commit_message>
renamed last episode to Practical adoptin
</commit_message>
<xml_diff>
--- a/instructors/01-Why_are_we_here.pptx
+++ b/instructors/01-Why_are_we_here.pptx
@@ -270,7 +270,7 @@
           <a:p>
             <a:fld id="{B1D4AFAA-5545-4348-866E-082827204B28}" type="datetimeFigureOut">
               <a:rPr lang="en-GB" smtClean="0"/>
-              <a:t>10/01/2024</a:t>
+              <a:t>15/01/2024</a:t>
             </a:fld>
             <a:endParaRPr lang="en-GB"/>
           </a:p>
@@ -842,7 +842,7 @@
           <a:p>
             <a:fld id="{CC29EC85-173F-467E-B364-65AD14726A23}" type="datetimeFigureOut">
               <a:rPr lang="en-GB" smtClean="0"/>
-              <a:t>10/01/2024</a:t>
+              <a:t>15/01/2024</a:t>
             </a:fld>
             <a:endParaRPr lang="en-GB"/>
           </a:p>
@@ -1059,7 +1059,7 @@
           <a:p>
             <a:fld id="{CC29EC85-173F-467E-B364-65AD14726A23}" type="datetimeFigureOut">
               <a:rPr lang="en-GB" smtClean="0"/>
-              <a:t>10/01/2024</a:t>
+              <a:t>15/01/2024</a:t>
             </a:fld>
             <a:endParaRPr lang="en-GB"/>
           </a:p>
@@ -1239,7 +1239,7 @@
           <a:p>
             <a:fld id="{CC29EC85-173F-467E-B364-65AD14726A23}" type="datetimeFigureOut">
               <a:rPr lang="en-GB" smtClean="0"/>
-              <a:t>10/01/2024</a:t>
+              <a:t>15/01/2024</a:t>
             </a:fld>
             <a:endParaRPr lang="en-GB"/>
           </a:p>
@@ -1602,7 +1602,7 @@
           <a:p>
             <a:fld id="{CC29EC85-173F-467E-B364-65AD14726A23}" type="datetimeFigureOut">
               <a:rPr lang="en-GB" smtClean="0"/>
-              <a:t>10/01/2024</a:t>
+              <a:t>15/01/2024</a:t>
             </a:fld>
             <a:endParaRPr lang="en-GB"/>
           </a:p>
@@ -1848,7 +1848,7 @@
           <a:p>
             <a:fld id="{CC29EC85-173F-467E-B364-65AD14726A23}" type="datetimeFigureOut">
               <a:rPr lang="en-GB" smtClean="0"/>
-              <a:t>10/01/2024</a:t>
+              <a:t>15/01/2024</a:t>
             </a:fld>
             <a:endParaRPr lang="en-GB"/>
           </a:p>
@@ -2080,7 +2080,7 @@
           <a:p>
             <a:fld id="{CC29EC85-173F-467E-B364-65AD14726A23}" type="datetimeFigureOut">
               <a:rPr lang="en-GB" smtClean="0"/>
-              <a:t>10/01/2024</a:t>
+              <a:t>15/01/2024</a:t>
             </a:fld>
             <a:endParaRPr lang="en-GB"/>
           </a:p>
@@ -2447,7 +2447,7 @@
           <a:p>
             <a:fld id="{CC29EC85-173F-467E-B364-65AD14726A23}" type="datetimeFigureOut">
               <a:rPr lang="en-GB" smtClean="0"/>
-              <a:t>10/01/2024</a:t>
+              <a:t>15/01/2024</a:t>
             </a:fld>
             <a:endParaRPr lang="en-GB"/>
           </a:p>
@@ -2565,7 +2565,7 @@
           <a:p>
             <a:fld id="{CC29EC85-173F-467E-B364-65AD14726A23}" type="datetimeFigureOut">
               <a:rPr lang="en-GB" smtClean="0"/>
-              <a:t>10/01/2024</a:t>
+              <a:t>15/01/2024</a:t>
             </a:fld>
             <a:endParaRPr lang="en-GB"/>
           </a:p>
@@ -2660,7 +2660,7 @@
           <a:p>
             <a:fld id="{CC29EC85-173F-467E-B364-65AD14726A23}" type="datetimeFigureOut">
               <a:rPr lang="en-GB" smtClean="0"/>
-              <a:t>10/01/2024</a:t>
+              <a:t>15/01/2024</a:t>
             </a:fld>
             <a:endParaRPr lang="en-GB"/>
           </a:p>
@@ -2937,7 +2937,7 @@
           <a:p>
             <a:fld id="{CC29EC85-173F-467E-B364-65AD14726A23}" type="datetimeFigureOut">
               <a:rPr lang="en-GB" smtClean="0"/>
-              <a:t>10/01/2024</a:t>
+              <a:t>15/01/2024</a:t>
             </a:fld>
             <a:endParaRPr lang="en-GB"/>
           </a:p>
@@ -3190,7 +3190,7 @@
           <a:p>
             <a:fld id="{CC29EC85-173F-467E-B364-65AD14726A23}" type="datetimeFigureOut">
               <a:rPr lang="en-GB" smtClean="0"/>
-              <a:t>10/01/2024</a:t>
+              <a:t>15/01/2024</a:t>
             </a:fld>
             <a:endParaRPr lang="en-GB"/>
           </a:p>
@@ -3402,7 +3402,7 @@
             <a:fld id="{CC29EC85-173F-467E-B364-65AD14726A23}" type="datetimeFigureOut">
               <a:rPr lang="en-GB" smtClean="0"/>
               <a:pPr/>
-              <a:t>10/01/2024</a:t>
+              <a:t>15/01/2024</a:t>
             </a:fld>
             <a:endParaRPr lang="en-GB"/>
           </a:p>
@@ -7049,7 +7049,7 @@
             <a:effectLst/>
             <a:extLst>
               <a:ext uri="{AF507438-7753-43e0-B8FC-AC1667EBCBE1}">
-                <a14:hiddenEffects xmlns="" xmlns:a14="http://schemas.microsoft.com/office/drawing/2010/main">
+                <a14:hiddenEffects xmlns:a14="http://schemas.microsoft.com/office/drawing/2010/main" xmlns="">
                   <a:effectLst>
                     <a:outerShdw dist="35921" dir="2700000" algn="ctr" rotWithShape="0">
                       <a:schemeClr val="bg2"/>
@@ -7111,7 +7111,7 @@
             <a:effectLst/>
             <a:extLst>
               <a:ext uri="{AF507438-7753-43e0-B8FC-AC1667EBCBE1}">
-                <a14:hiddenEffects xmlns="" xmlns:a14="http://schemas.microsoft.com/office/drawing/2010/main">
+                <a14:hiddenEffects xmlns:a14="http://schemas.microsoft.com/office/drawing/2010/main" xmlns="">
                   <a:effectLst>
                     <a:outerShdw dist="35921" dir="2700000" algn="ctr" rotWithShape="0">
                       <a:schemeClr val="bg2"/>
@@ -7173,7 +7173,7 @@
             <a:effectLst/>
             <a:extLst>
               <a:ext uri="{AF507438-7753-43e0-B8FC-AC1667EBCBE1}">
-                <a14:hiddenEffects xmlns="" xmlns:a14="http://schemas.microsoft.com/office/drawing/2010/main">
+                <a14:hiddenEffects xmlns:a14="http://schemas.microsoft.com/office/drawing/2010/main" xmlns="">
                   <a:effectLst>
                     <a:outerShdw dist="35921" dir="2700000" algn="ctr" rotWithShape="0">
                       <a:schemeClr val="bg2"/>
@@ -7372,7 +7372,7 @@
           <a:effectLst/>
           <a:extLst>
             <a:ext uri="{AF507438-7753-43e0-B8FC-AC1667EBCBE1}">
-              <a14:hiddenEffects xmlns="" xmlns:a14="http://schemas.microsoft.com/office/drawing/2010/main">
+              <a14:hiddenEffects xmlns:a14="http://schemas.microsoft.com/office/drawing/2010/main" xmlns="">
                 <a:effectLst>
                   <a:outerShdw dist="35921" dir="2700000" algn="ctr" rotWithShape="0">
                     <a:schemeClr val="bg2"/>
@@ -7703,7 +7703,7 @@
             <a:effectLst/>
             <a:extLst>
               <a:ext uri="{AF507438-7753-43e0-B8FC-AC1667EBCBE1}">
-                <a14:hiddenEffects xmlns="" xmlns:a14="http://schemas.microsoft.com/office/drawing/2010/main">
+                <a14:hiddenEffects xmlns:a14="http://schemas.microsoft.com/office/drawing/2010/main" xmlns="">
                   <a:effectLst>
                     <a:outerShdw dist="35921" dir="2700000" algn="ctr" rotWithShape="0">
                       <a:schemeClr val="bg2"/>
@@ -7765,7 +7765,7 @@
             <a:effectLst/>
             <a:extLst>
               <a:ext uri="{AF507438-7753-43e0-B8FC-AC1667EBCBE1}">
-                <a14:hiddenEffects xmlns="" xmlns:a14="http://schemas.microsoft.com/office/drawing/2010/main">
+                <a14:hiddenEffects xmlns:a14="http://schemas.microsoft.com/office/drawing/2010/main" xmlns="">
                   <a:effectLst>
                     <a:outerShdw dist="35921" dir="2700000" algn="ctr" rotWithShape="0">
                       <a:schemeClr val="bg2"/>
@@ -7842,7 +7842,7 @@
             <a:effectLst/>
             <a:extLst>
               <a:ext uri="{AF507438-7753-43e0-B8FC-AC1667EBCBE1}">
-                <a14:hiddenEffects xmlns="" xmlns:a14="http://schemas.microsoft.com/office/drawing/2010/main">
+                <a14:hiddenEffects xmlns:a14="http://schemas.microsoft.com/office/drawing/2010/main" xmlns="">
                   <a:effectLst>
                     <a:outerShdw dist="35921" dir="2700000" algn="ctr" rotWithShape="0">
                       <a:schemeClr val="bg2"/>
@@ -7904,7 +7904,7 @@
             <a:effectLst/>
             <a:extLst>
               <a:ext uri="{AF507438-7753-43e0-B8FC-AC1667EBCBE1}">
-                <a14:hiddenEffects xmlns="" xmlns:a14="http://schemas.microsoft.com/office/drawing/2010/main">
+                <a14:hiddenEffects xmlns:a14="http://schemas.microsoft.com/office/drawing/2010/main" xmlns="">
                   <a:effectLst>
                     <a:outerShdw dist="35921" dir="2700000" algn="ctr" rotWithShape="0">
                       <a:schemeClr val="bg2"/>
@@ -9137,7 +9137,7 @@
           <a:effectLst/>
           <a:extLst>
             <a:ext uri="{AF507438-7753-43e0-B8FC-AC1667EBCBE1}">
-              <a14:hiddenEffects xmlns="" xmlns:a14="http://schemas.microsoft.com/office/drawing/2010/main">
+              <a14:hiddenEffects xmlns:a14="http://schemas.microsoft.com/office/drawing/2010/main" xmlns="">
                 <a:effectLst>
                   <a:outerShdw dist="35921" dir="2700000" algn="ctr" rotWithShape="0">
                     <a:schemeClr val="bg2"/>
@@ -11789,9 +11789,10 @@
           </a:p>
           <a:p>
             <a:r>
-              <a:rPr lang="en-GB" sz="4000" dirty="0"/>
-              <a:t>Wrap up</a:t>
-            </a:r>
+              <a:rPr lang="pl-PL" sz="4000"/>
+              <a:t>Practical adoption</a:t>
+            </a:r>
+            <a:endParaRPr lang="en-GB" sz="4000" dirty="0"/>
           </a:p>
         </p:txBody>
       </p:sp>

</xml_diff>